<commit_message>
feat: seção Partes Envolvidas na Proposta de Honorários
- Formulário permite adicionar/remover N partes (empresa, sócios, avalistas)
- Partes são enviadas ao backend e exibidas no slide "Seu Caso" do PPTX
- Backend concatena partes com \n em {{PARTES_LISTADAS}}; {{PARTES_S3_CLEAR}} esvaziado
- make_proposta_template.py refatorado com SLIDE_RULES por slide
- Template proposta.pptx regenerado com novos marcadores

Co-Authored-By: Claude Sonnet 4.6 <noreply@anthropic.com>
</commit_message>
<xml_diff>
--- a/templates/proposta.pptx
+++ b/templates/proposta.pptx
@@ -6694,7 +6694,7 @@
                 </a:solidFill>
                 <a:latin typeface="Georgia"/>
               </a:rPr>
-              <a:t>{{SOLICITANTE_EMPRESA}}</a:t>
+              <a:t>{{PARTES_LISTADAS}}</a:t>
             </a:r>
             <a:r>
               <a:rPr sz="2000" b="1" i="0" dirty="0" err="1">
@@ -6760,7 +6760,7 @@
                 </a:solidFill>
                 <a:latin typeface="Calibri"/>
               </a:rPr>
-              <a:t>{{SOLICITANTE_NOME}}</a:t>
+              <a:t>{{PARTES_S3_CLEAR}}</a:t>
             </a:r>
           </a:p>
         </p:txBody>

</xml_diff>

<commit_message>
feat: adiciona valor da causa e percentuais de honorários na proposta
- Campo 'Valor Total da Causa' no formulário de proposta (obrigatório)
- Cálculo automático de PERC_OP1 e PERC_OP2_AV (% dos honorários vs causa)
- Slide 3: exibe valor da causa na seção de partes envolvidas
- Slide 5: redesenhado com causa, opções com %, e 3 diferenciais BlindSafe
- Slides 6 e 7: linha mostrando % dos honorários em relação ao valor da causa

Co-Authored-By: Claude Sonnet 4.6 <noreply@anthropic.com>
</commit_message>
<xml_diff>
--- a/templates/proposta.pptx
+++ b/templates/proposta.pptx
@@ -131,6 +131,130 @@
 </p:presentation>
 </file>
 
+<file path=ppt/revisionInfo.xml><?xml version="1.0" encoding="utf-8"?>
+<p1510:revInfo xmlns:a="http://schemas.openxmlformats.org/drawingml/2006/main" xmlns:r="http://schemas.openxmlformats.org/officeDocument/2006/relationships" xmlns:p1510="http://schemas.microsoft.com/office/powerpoint/2015/10/main">
+  <p1510:revLst>
+    <p1510:client id="{78378EB5-88A4-42E7-AFC1-6CA640D4CBEF}" v="2" dt="2026-06-28T14:54:01.935"/>
+  </p1510:revLst>
+</p1510:revInfo>
+</file>
+
+<file path=ppt/changesInfos/changesInfo1.xml><?xml version="1.0" encoding="utf-8"?>
+<pc:chgInfo xmlns:a="http://schemas.openxmlformats.org/drawingml/2006/main" xmlns:r="http://schemas.openxmlformats.org/officeDocument/2006/relationships" xmlns:ac="http://schemas.microsoft.com/office/drawing/2013/main/command" xmlns:pc="http://schemas.microsoft.com/office/powerpoint/2013/main/command">
+  <pc:docChgLst>
+    <pc:chgData name="Paulo Ricardo" userId="cb452491663e6e9a" providerId="LiveId" clId="{AA48573D-714E-4ABD-867E-41884C69033F}"/>
+    <pc:docChg chg="undo custSel modSld">
+      <pc:chgData name="Paulo Ricardo" userId="cb452491663e6e9a" providerId="LiveId" clId="{AA48573D-714E-4ABD-867E-41884C69033F}" dt="2026-06-28T14:58:33.606" v="148" actId="255"/>
+      <pc:docMkLst>
+        <pc:docMk/>
+      </pc:docMkLst>
+      <pc:sldChg chg="modSp mod">
+        <pc:chgData name="Paulo Ricardo" userId="cb452491663e6e9a" providerId="LiveId" clId="{AA48573D-714E-4ABD-867E-41884C69033F}" dt="2026-06-28T14:44:33.570" v="0" actId="1076"/>
+        <pc:sldMkLst>
+          <pc:docMk/>
+          <pc:sldMk cId="0" sldId="258"/>
+        </pc:sldMkLst>
+        <pc:spChg chg="mod">
+          <ac:chgData name="Paulo Ricardo" userId="cb452491663e6e9a" providerId="LiveId" clId="{AA48573D-714E-4ABD-867E-41884C69033F}" dt="2026-06-28T14:44:33.570" v="0" actId="1076"/>
+          <ac:spMkLst>
+            <pc:docMk/>
+            <pc:sldMk cId="0" sldId="258"/>
+            <ac:spMk id="28" creationId="{00000000-0000-0000-0000-000000000000}"/>
+          </ac:spMkLst>
+        </pc:spChg>
+      </pc:sldChg>
+      <pc:sldChg chg="delSp modSp mod">
+        <pc:chgData name="Paulo Ricardo" userId="cb452491663e6e9a" providerId="LiveId" clId="{AA48573D-714E-4ABD-867E-41884C69033F}" dt="2026-06-28T14:58:33.606" v="148" actId="255"/>
+        <pc:sldMkLst>
+          <pc:docMk/>
+          <pc:sldMk cId="0" sldId="260"/>
+        </pc:sldMkLst>
+        <pc:spChg chg="mod">
+          <ac:chgData name="Paulo Ricardo" userId="cb452491663e6e9a" providerId="LiveId" clId="{AA48573D-714E-4ABD-867E-41884C69033F}" dt="2026-06-28T14:46:23.655" v="3" actId="1076"/>
+          <ac:spMkLst>
+            <pc:docMk/>
+            <pc:sldMk cId="0" sldId="260"/>
+            <ac:spMk id="6" creationId="{00000000-0000-0000-0000-000000000000}"/>
+          </ac:spMkLst>
+        </pc:spChg>
+        <pc:spChg chg="mod">
+          <ac:chgData name="Paulo Ricardo" userId="cb452491663e6e9a" providerId="LiveId" clId="{AA48573D-714E-4ABD-867E-41884C69033F}" dt="2026-06-28T14:46:12.662" v="2" actId="1076"/>
+          <ac:spMkLst>
+            <pc:docMk/>
+            <pc:sldMk cId="0" sldId="260"/>
+            <ac:spMk id="7" creationId="{00000000-0000-0000-0000-000000000000}"/>
+          </ac:spMkLst>
+        </pc:spChg>
+        <pc:spChg chg="del">
+          <ac:chgData name="Paulo Ricardo" userId="cb452491663e6e9a" providerId="LiveId" clId="{AA48573D-714E-4ABD-867E-41884C69033F}" dt="2026-06-28T14:45:43.646" v="1" actId="478"/>
+          <ac:spMkLst>
+            <pc:docMk/>
+            <pc:sldMk cId="0" sldId="260"/>
+            <ac:spMk id="8" creationId="{00000000-0000-0000-0000-000000000000}"/>
+          </ac:spMkLst>
+        </pc:spChg>
+        <pc:spChg chg="mod">
+          <ac:chgData name="Paulo Ricardo" userId="cb452491663e6e9a" providerId="LiveId" clId="{AA48573D-714E-4ABD-867E-41884C69033F}" dt="2026-06-28T14:47:22.826" v="5" actId="14100"/>
+          <ac:spMkLst>
+            <pc:docMk/>
+            <pc:sldMk cId="0" sldId="260"/>
+            <ac:spMk id="11" creationId="{00000000-0000-0000-0000-000000000000}"/>
+          </ac:spMkLst>
+        </pc:spChg>
+        <pc:spChg chg="mod">
+          <ac:chgData name="Paulo Ricardo" userId="cb452491663e6e9a" providerId="LiveId" clId="{AA48573D-714E-4ABD-867E-41884C69033F}" dt="2026-06-28T14:48:19.343" v="8" actId="1076"/>
+          <ac:spMkLst>
+            <pc:docMk/>
+            <pc:sldMk cId="0" sldId="260"/>
+            <ac:spMk id="14" creationId="{00000000-0000-0000-0000-000000000000}"/>
+          </ac:spMkLst>
+        </pc:spChg>
+        <pc:spChg chg="mod">
+          <ac:chgData name="Paulo Ricardo" userId="cb452491663e6e9a" providerId="LiveId" clId="{AA48573D-714E-4ABD-867E-41884C69033F}" dt="2026-06-28T14:47:41.652" v="6" actId="14100"/>
+          <ac:spMkLst>
+            <pc:docMk/>
+            <pc:sldMk cId="0" sldId="260"/>
+            <ac:spMk id="15" creationId="{00000000-0000-0000-0000-000000000000}"/>
+          </ac:spMkLst>
+        </pc:spChg>
+        <pc:spChg chg="mod">
+          <ac:chgData name="Paulo Ricardo" userId="cb452491663e6e9a" providerId="LiveId" clId="{AA48573D-714E-4ABD-867E-41884C69033F}" dt="2026-06-28T14:47:56.500" v="7" actId="1076"/>
+          <ac:spMkLst>
+            <pc:docMk/>
+            <pc:sldMk cId="0" sldId="260"/>
+            <ac:spMk id="18" creationId="{00000000-0000-0000-0000-000000000000}"/>
+          </ac:spMkLst>
+        </pc:spChg>
+        <pc:spChg chg="mod">
+          <ac:chgData name="Paulo Ricardo" userId="cb452491663e6e9a" providerId="LiveId" clId="{AA48573D-714E-4ABD-867E-41884C69033F}" dt="2026-06-28T14:50:05.205" v="26" actId="20577"/>
+          <ac:spMkLst>
+            <pc:docMk/>
+            <pc:sldMk cId="0" sldId="260"/>
+            <ac:spMk id="26" creationId="{00000000-0000-0000-0000-000000000000}"/>
+          </ac:spMkLst>
+        </pc:spChg>
+        <pc:spChg chg="mod">
+          <ac:chgData name="Paulo Ricardo" userId="cb452491663e6e9a" providerId="LiveId" clId="{AA48573D-714E-4ABD-867E-41884C69033F}" dt="2026-06-28T14:50:58.514" v="35" actId="20577"/>
+          <ac:spMkLst>
+            <pc:docMk/>
+            <pc:sldMk cId="0" sldId="260"/>
+            <ac:spMk id="29" creationId="{00000000-0000-0000-0000-000000000000}"/>
+          </ac:spMkLst>
+        </pc:spChg>
+        <pc:spChg chg="mod">
+          <ac:chgData name="Paulo Ricardo" userId="cb452491663e6e9a" providerId="LiveId" clId="{AA48573D-714E-4ABD-867E-41884C69033F}" dt="2026-06-28T14:58:33.606" v="148" actId="255"/>
+          <ac:spMkLst>
+            <pc:docMk/>
+            <pc:sldMk cId="0" sldId="260"/>
+            <ac:spMk id="31" creationId="{00000000-0000-0000-0000-000000000000}"/>
+          </ac:spMkLst>
+        </pc:spChg>
+      </pc:sldChg>
+    </pc:docChg>
+  </pc:docChgLst>
+</pc:chgInfo>
+</file>
+
 <file path=ppt/slideLayouts/slideLayout1.xml><?xml version="1.0" encoding="utf-8"?>
 <p:sldLayout xmlns:a="http://schemas.openxmlformats.org/drawingml/2006/main" xmlns:r="http://schemas.openxmlformats.org/officeDocument/2006/relationships" xmlns:p="http://schemas.openxmlformats.org/presentationml/2006/main" type="title" preserve="1">
   <p:cSld name="Title Slide">
@@ -310,7 +434,7 @@
           <a:p>
             <a:fld id="{5BCAD085-E8A6-8845-BD4E-CB4CCA059FC4}" type="datetimeFigureOut">
               <a:rPr lang="en-US" smtClean="0"/>
-              <a:t>4/30/2026</a:t>
+              <a:t>6/28/2026</a:t>
             </a:fld>
             <a:endParaRPr lang="en-US"/>
           </a:p>
@@ -478,7 +602,7 @@
           <a:p>
             <a:fld id="{5BCAD085-E8A6-8845-BD4E-CB4CCA059FC4}" type="datetimeFigureOut">
               <a:rPr lang="en-US" smtClean="0"/>
-              <a:t>4/30/2026</a:t>
+              <a:t>6/28/2026</a:t>
             </a:fld>
             <a:endParaRPr lang="en-US"/>
           </a:p>
@@ -656,7 +780,7 @@
           <a:p>
             <a:fld id="{5BCAD085-E8A6-8845-BD4E-CB4CCA059FC4}" type="datetimeFigureOut">
               <a:rPr lang="en-US" smtClean="0"/>
-              <a:t>4/30/2026</a:t>
+              <a:t>6/28/2026</a:t>
             </a:fld>
             <a:endParaRPr lang="en-US"/>
           </a:p>
@@ -824,7 +948,7 @@
           <a:p>
             <a:fld id="{5BCAD085-E8A6-8845-BD4E-CB4CCA059FC4}" type="datetimeFigureOut">
               <a:rPr lang="en-US" smtClean="0"/>
-              <a:t>4/30/2026</a:t>
+              <a:t>6/28/2026</a:t>
             </a:fld>
             <a:endParaRPr lang="en-US"/>
           </a:p>
@@ -1069,7 +1193,7 @@
           <a:p>
             <a:fld id="{5BCAD085-E8A6-8845-BD4E-CB4CCA059FC4}" type="datetimeFigureOut">
               <a:rPr lang="en-US" smtClean="0"/>
-              <a:t>4/30/2026</a:t>
+              <a:t>6/28/2026</a:t>
             </a:fld>
             <a:endParaRPr lang="en-US"/>
           </a:p>
@@ -1354,7 +1478,7 @@
           <a:p>
             <a:fld id="{5BCAD085-E8A6-8845-BD4E-CB4CCA059FC4}" type="datetimeFigureOut">
               <a:rPr lang="en-US" smtClean="0"/>
-              <a:t>4/30/2026</a:t>
+              <a:t>6/28/2026</a:t>
             </a:fld>
             <a:endParaRPr lang="en-US"/>
           </a:p>
@@ -1773,7 +1897,7 @@
           <a:p>
             <a:fld id="{5BCAD085-E8A6-8845-BD4E-CB4CCA059FC4}" type="datetimeFigureOut">
               <a:rPr lang="en-US" smtClean="0"/>
-              <a:t>4/30/2026</a:t>
+              <a:t>6/28/2026</a:t>
             </a:fld>
             <a:endParaRPr lang="en-US"/>
           </a:p>
@@ -1890,7 +2014,7 @@
           <a:p>
             <a:fld id="{5BCAD085-E8A6-8845-BD4E-CB4CCA059FC4}" type="datetimeFigureOut">
               <a:rPr lang="en-US" smtClean="0"/>
-              <a:t>4/30/2026</a:t>
+              <a:t>6/28/2026</a:t>
             </a:fld>
             <a:endParaRPr lang="en-US"/>
           </a:p>
@@ -1985,7 +2109,7 @@
           <a:p>
             <a:fld id="{5BCAD085-E8A6-8845-BD4E-CB4CCA059FC4}" type="datetimeFigureOut">
               <a:rPr lang="en-US" smtClean="0"/>
-              <a:t>4/30/2026</a:t>
+              <a:t>6/28/2026</a:t>
             </a:fld>
             <a:endParaRPr lang="en-US"/>
           </a:p>
@@ -2260,7 +2384,7 @@
           <a:p>
             <a:fld id="{5BCAD085-E8A6-8845-BD4E-CB4CCA059FC4}" type="datetimeFigureOut">
               <a:rPr lang="en-US" smtClean="0"/>
-              <a:t>4/30/2026</a:t>
+              <a:t>6/28/2026</a:t>
             </a:fld>
             <a:endParaRPr lang="en-US"/>
           </a:p>
@@ -2512,7 +2636,7 @@
           <a:p>
             <a:fld id="{5BCAD085-E8A6-8845-BD4E-CB4CCA059FC4}" type="datetimeFigureOut">
               <a:rPr lang="en-US" smtClean="0"/>
-              <a:t>4/30/2026</a:t>
+              <a:t>6/28/2026</a:t>
             </a:fld>
             <a:endParaRPr lang="en-US"/>
           </a:p>
@@ -2723,7 +2847,7 @@
           <a:p>
             <a:fld id="{5BCAD085-E8A6-8845-BD4E-CB4CCA059FC4}" type="datetimeFigureOut">
               <a:rPr lang="en-US" smtClean="0"/>
-              <a:t>4/30/2026</a:t>
+              <a:t>6/28/2026</a:t>
             </a:fld>
             <a:endParaRPr lang="en-US"/>
           </a:p>
@@ -3555,39 +3679,6 @@
               </a:rPr>
               <a:t>{{SOLICITANTE_EMPRESA}}</a:t>
             </a:r>
-            <a:r>
-              <a:rPr b="0" i="0" dirty="0" err="1">
-                <a:solidFill>
-                  <a:srgbClr val="8899AA"/>
-                </a:solidFill>
-                <a:latin typeface="Calibri"/>
-              </a:rPr>
-              <a:t/>
-            </a:r>
-            <a:r>
-              <a:rPr b="0" i="0" dirty="0">
-                <a:solidFill>
-                  <a:srgbClr val="8899AA"/>
-                </a:solidFill>
-                <a:latin typeface="Calibri"/>
-              </a:rPr>
-              <a:t/>
-            </a:r>
-            <a:r>
-              <a:rPr b="0" i="0" dirty="0" err="1">
-                <a:solidFill>
-                  <a:srgbClr val="8899AA"/>
-                </a:solidFill>
-                <a:latin typeface="Calibri"/>
-              </a:rPr>
-              <a:t/>
-            </a:r>
-            <a:endParaRPr b="0" i="0" dirty="0">
-              <a:solidFill>
-                <a:srgbClr val="8899AA"/>
-              </a:solidFill>
-              <a:latin typeface="Calibri"/>
-            </a:endParaRPr>
           </a:p>
         </p:txBody>
       </p:sp>
@@ -3697,33 +3788,6 @@
                 <a:latin typeface="Calibri"/>
               </a:rPr>
               <a:t>{{ASSUNTO}}</a:t>
-            </a:r>
-            <a:r>
-              <a:rPr b="0" i="0" dirty="0">
-                <a:solidFill>
-                  <a:srgbClr val="8899AA"/>
-                </a:solidFill>
-                <a:latin typeface="Calibri"/>
-              </a:rPr>
-              <a:t/>
-            </a:r>
-            <a:r>
-              <a:rPr b="0" i="0" dirty="0" err="1">
-                <a:solidFill>
-                  <a:srgbClr val="8899AA"/>
-                </a:solidFill>
-                <a:latin typeface="Calibri"/>
-              </a:rPr>
-              <a:t/>
-            </a:r>
-            <a:r>
-              <a:rPr b="0" i="0" dirty="0">
-                <a:solidFill>
-                  <a:srgbClr val="8899AA"/>
-                </a:solidFill>
-                <a:latin typeface="Calibri"/>
-              </a:rPr>
-              <a:t/>
             </a:r>
           </a:p>
         </p:txBody>
@@ -6513,33 +6577,6 @@
               </a:rPr>
               <a:t>{{ASSUNTO}}</a:t>
             </a:r>
-            <a:r>
-              <a:rPr sz="2000" b="1" i="0" dirty="0">
-                <a:solidFill>
-                  <a:srgbClr val="FFFFFF"/>
-                </a:solidFill>
-                <a:latin typeface="Georgia"/>
-              </a:rPr>
-              <a:t/>
-            </a:r>
-            <a:r>
-              <a:rPr sz="2000" b="1" i="0" dirty="0" err="1">
-                <a:solidFill>
-                  <a:srgbClr val="FFFFFF"/>
-                </a:solidFill>
-                <a:latin typeface="Georgia"/>
-              </a:rPr>
-              <a:t/>
-            </a:r>
-            <a:r>
-              <a:rPr sz="2000" b="1" i="0" dirty="0">
-                <a:solidFill>
-                  <a:srgbClr val="FFFFFF"/>
-                </a:solidFill>
-                <a:latin typeface="Georgia"/>
-              </a:rPr>
-              <a:t/>
-            </a:r>
           </a:p>
         </p:txBody>
       </p:sp>
@@ -6696,39 +6733,6 @@
               </a:rPr>
               <a:t>{{PARTES_LISTADAS}}</a:t>
             </a:r>
-            <a:r>
-              <a:rPr sz="2000" b="1" i="0" dirty="0" err="1">
-                <a:solidFill>
-                  <a:srgbClr val="FFFFFF"/>
-                </a:solidFill>
-                <a:latin typeface="Georgia"/>
-              </a:rPr>
-              <a:t/>
-            </a:r>
-            <a:r>
-              <a:rPr sz="2000" b="1" i="0" dirty="0">
-                <a:solidFill>
-                  <a:srgbClr val="FFFFFF"/>
-                </a:solidFill>
-                <a:latin typeface="Georgia"/>
-              </a:rPr>
-              <a:t/>
-            </a:r>
-            <a:r>
-              <a:rPr sz="2000" b="1" i="0" dirty="0" err="1">
-                <a:solidFill>
-                  <a:srgbClr val="FFFFFF"/>
-                </a:solidFill>
-                <a:latin typeface="Georgia"/>
-              </a:rPr>
-              <a:t/>
-            </a:r>
-            <a:endParaRPr sz="2000" b="1" i="0" dirty="0">
-              <a:solidFill>
-                <a:srgbClr val="FFFFFF"/>
-              </a:solidFill>
-              <a:latin typeface="Georgia"/>
-            </a:endParaRPr>
           </a:p>
         </p:txBody>
       </p:sp>
@@ -7268,6 +7272,118 @@
                 <a:latin typeface="Calibri"/>
               </a:rPr>
               <a:t>  |  contato@blindsafe.com.br  |  (21) 3437-5022</a:t>
+            </a:r>
+          </a:p>
+        </p:txBody>
+      </p:sp>
+      <p:sp>
+        <p:nvSpPr>
+          <p:cNvPr id="26" name="Rectangle 25"/>
+          <p:cNvSpPr/>
+          <p:nvPr/>
+        </p:nvSpPr>
+        <p:spPr>
+          <a:xfrm>
+            <a:off x="621792" y="6680000"/>
+            <a:ext cx="6400800" cy="16000"/>
+          </a:xfrm>
+          <a:prstGeom prst="rect">
+            <a:avLst/>
+          </a:prstGeom>
+          <a:solidFill>
+            <a:srgbClr val="2A4070"/>
+          </a:solidFill>
+          <a:ln>
+            <a:noFill/>
+          </a:ln>
+        </p:spPr>
+        <p:style>
+          <a:lnRef idx="1">
+            <a:schemeClr val="accent1"/>
+          </a:lnRef>
+          <a:fillRef idx="3">
+            <a:schemeClr val="accent1"/>
+          </a:fillRef>
+          <a:effectRef idx="2">
+            <a:schemeClr val="accent1"/>
+          </a:effectRef>
+          <a:fontRef idx="minor">
+            <a:schemeClr val="lt1"/>
+          </a:fontRef>
+        </p:style>
+        <p:txBody>
+          <a:bodyPr rtlCol="0" anchor="ctr"/>
+          <a:lstStyle/>
+          <a:p>
+            <a:pPr algn="ctr"/>
+            <a:endParaRPr/>
+          </a:p>
+        </p:txBody>
+      </p:sp>
+      <p:sp>
+        <p:nvSpPr>
+          <p:cNvPr id="27" name="TextBox 26"/>
+          <p:cNvSpPr txBox="1"/>
+          <p:nvPr/>
+        </p:nvSpPr>
+        <p:spPr>
+          <a:xfrm>
+            <a:off x="621792" y="6740000"/>
+            <a:ext cx="6400800" cy="220000"/>
+          </a:xfrm>
+          <a:prstGeom prst="rect">
+            <a:avLst/>
+          </a:prstGeom>
+          <a:noFill/>
+        </p:spPr>
+        <p:txBody>
+          <a:bodyPr wrap="square" lIns="0" tIns="0" rIns="0" bIns="0">
+            <a:spAutoFit/>
+          </a:bodyPr>
+          <a:lstStyle/>
+          <a:p>
+            <a:pPr algn="l"/>
+            <a:r>
+              <a:rPr sz="800" b="1" i="0">
+                <a:solidFill>
+                  <a:srgbClr val="8899AA"/>
+                </a:solidFill>
+              </a:rPr>
+              <a:t>VALOR TOTAL DA CAUSA</a:t>
+            </a:r>
+          </a:p>
+        </p:txBody>
+      </p:sp>
+      <p:sp>
+        <p:nvSpPr>
+          <p:cNvPr id="28" name="TextBox 27"/>
+          <p:cNvSpPr txBox="1"/>
+          <p:nvPr/>
+        </p:nvSpPr>
+        <p:spPr>
+          <a:xfrm>
+            <a:off x="603504" y="6883196"/>
+            <a:ext cx="6400800" cy="400000"/>
+          </a:xfrm>
+          <a:prstGeom prst="rect">
+            <a:avLst/>
+          </a:prstGeom>
+          <a:noFill/>
+        </p:spPr>
+        <p:txBody>
+          <a:bodyPr wrap="square" lIns="0" tIns="0" rIns="0" bIns="0">
+            <a:spAutoFit/>
+          </a:bodyPr>
+          <a:lstStyle/>
+          <a:p>
+            <a:pPr algn="l"/>
+            <a:r>
+              <a:rPr sz="2000" b="1" i="0" dirty="0">
+                <a:solidFill>
+                  <a:srgbClr val="E5CC7A"/>
+                </a:solidFill>
+              </a:rPr>
+              <a:t>{{VALOR_CAUSA}}</a:t>
             </a:r>
           </a:p>
         </p:txBody>
@@ -9539,8 +9655,52 @@
         </p:nvSpPr>
         <p:spPr>
           <a:xfrm>
+            <a:off x="0" y="580000"/>
+            <a:ext cx="7562850" cy="10688638"/>
+          </a:xfrm>
+          <a:prstGeom prst="rect">
+            <a:avLst/>
+          </a:prstGeom>
+          <a:solidFill>
+            <a:srgbClr val="0D1B3E"/>
+          </a:solidFill>
+          <a:ln>
+            <a:noFill/>
+          </a:ln>
+        </p:spPr>
+        <p:style>
+          <a:lnRef idx="1">
+            <a:schemeClr val="accent1"/>
+          </a:lnRef>
+          <a:fillRef idx="3">
+            <a:schemeClr val="accent1"/>
+          </a:fillRef>
+          <a:effectRef idx="2">
+            <a:schemeClr val="accent1"/>
+          </a:effectRef>
+          <a:fontRef idx="minor">
+            <a:schemeClr val="lt1"/>
+          </a:fontRef>
+        </p:style>
+        <p:txBody>
+          <a:bodyPr rtlCol="0" anchor="ctr"/>
+          <a:lstStyle/>
+          <a:p>
+            <a:pPr algn="ctr"/>
+            <a:endParaRPr/>
+          </a:p>
+        </p:txBody>
+      </p:sp>
+      <p:sp>
+        <p:nvSpPr>
+          <p:cNvPr id="3" name="Rectangle 2"/>
+          <p:cNvSpPr/>
+          <p:nvPr/>
+        </p:nvSpPr>
+        <p:spPr>
+          <a:xfrm>
             <a:off x="0" y="0"/>
-            <a:ext cx="7562088" cy="50292"/>
+            <a:ext cx="7562850" cy="18000"/>
           </a:xfrm>
           <a:prstGeom prst="rect">
             <a:avLst/>
@@ -9577,23 +9737,159 @@
       </p:sp>
       <p:sp>
         <p:nvSpPr>
-          <p:cNvPr id="3" name="Oval 2"/>
+          <p:cNvPr id="4" name="TextBox 3"/>
+          <p:cNvSpPr txBox="1"/>
+          <p:nvPr/>
+        </p:nvSpPr>
+        <p:spPr>
+          <a:xfrm>
+            <a:off x="384048" y="100000"/>
+            <a:ext cx="6793992" cy="480000"/>
+          </a:xfrm>
+          <a:prstGeom prst="rect">
+            <a:avLst/>
+          </a:prstGeom>
+          <a:noFill/>
+        </p:spPr>
+        <p:txBody>
+          <a:bodyPr wrap="square" lIns="0" tIns="0" rIns="0" bIns="0">
+            <a:spAutoFit/>
+          </a:bodyPr>
+          <a:lstStyle/>
+          <a:p>
+            <a:pPr algn="l"/>
+            <a:r>
+              <a:rPr sz="2600" b="1" i="0" dirty="0">
+                <a:solidFill>
+                  <a:srgbClr val="FFFFFF"/>
+                </a:solidFill>
+              </a:rPr>
+              <a:t>Seu Investimento </a:t>
+            </a:r>
+            <a:r>
+              <a:rPr sz="2600" b="1" i="0" dirty="0" err="1">
+                <a:solidFill>
+                  <a:srgbClr val="FFFFFF"/>
+                </a:solidFill>
+              </a:rPr>
+              <a:t>em</a:t>
+            </a:r>
+            <a:r>
+              <a:rPr sz="2600" b="1" i="0" dirty="0">
+                <a:solidFill>
+                  <a:srgbClr val="FFFFFF"/>
+                </a:solidFill>
+              </a:rPr>
+              <a:t> </a:t>
+            </a:r>
+            <a:r>
+              <a:rPr sz="2600" b="1" i="0" dirty="0" err="1">
+                <a:solidFill>
+                  <a:srgbClr val="FFFFFF"/>
+                </a:solidFill>
+              </a:rPr>
+              <a:t>Perspectiva</a:t>
+            </a:r>
+            <a:endParaRPr sz="2600" b="1" i="0" dirty="0">
+              <a:solidFill>
+                <a:srgbClr val="FFFFFF"/>
+              </a:solidFill>
+            </a:endParaRPr>
+          </a:p>
+          <a:p>
+            <a:pPr algn="l">
+              <a:spcBef>
+                <a:spcPts val="600"/>
+              </a:spcBef>
+            </a:pPr>
+            <a:r>
+              <a:rPr sz="1100" b="0" i="1" dirty="0" err="1">
+                <a:solidFill>
+                  <a:srgbClr val="E5CC7A"/>
+                </a:solidFill>
+              </a:rPr>
+              <a:t>Transparência</a:t>
+            </a:r>
+            <a:r>
+              <a:rPr sz="1100" b="0" i="1" dirty="0">
+                <a:solidFill>
+                  <a:srgbClr val="E5CC7A"/>
+                </a:solidFill>
+              </a:rPr>
+              <a:t> total. </a:t>
+            </a:r>
+            <a:r>
+              <a:rPr sz="1100" b="0" i="1" dirty="0" err="1">
+                <a:solidFill>
+                  <a:srgbClr val="E5CC7A"/>
+                </a:solidFill>
+              </a:rPr>
+              <a:t>Honorários</a:t>
+            </a:r>
+            <a:r>
+              <a:rPr sz="1100" b="0" i="1" dirty="0">
+                <a:solidFill>
+                  <a:srgbClr val="E5CC7A"/>
+                </a:solidFill>
+              </a:rPr>
+              <a:t> </a:t>
+            </a:r>
+            <a:r>
+              <a:rPr sz="1100" b="0" i="1" dirty="0" err="1">
+                <a:solidFill>
+                  <a:srgbClr val="E5CC7A"/>
+                </a:solidFill>
+              </a:rPr>
+              <a:t>justos</a:t>
+            </a:r>
+            <a:r>
+              <a:rPr sz="1100" b="0" i="1" dirty="0">
+                <a:solidFill>
+                  <a:srgbClr val="E5CC7A"/>
+                </a:solidFill>
+              </a:rPr>
+              <a:t>. Sem </a:t>
+            </a:r>
+            <a:r>
+              <a:rPr sz="1100" b="0" i="1" dirty="0" err="1">
+                <a:solidFill>
+                  <a:srgbClr val="E5CC7A"/>
+                </a:solidFill>
+              </a:rPr>
+              <a:t>surpresas</a:t>
+            </a:r>
+            <a:r>
+              <a:rPr sz="1100" b="0" i="1" dirty="0">
+                <a:solidFill>
+                  <a:srgbClr val="E5CC7A"/>
+                </a:solidFill>
+              </a:rPr>
+              <a:t>.</a:t>
+            </a:r>
+          </a:p>
+        </p:txBody>
+      </p:sp>
+      <p:sp>
+        <p:nvSpPr>
+          <p:cNvPr id="5" name="Rectangle 4"/>
           <p:cNvSpPr/>
           <p:nvPr/>
         </p:nvSpPr>
         <p:spPr>
           <a:xfrm>
-            <a:off x="-2286000" y="6400800"/>
-            <a:ext cx="6400800" cy="6400800"/>
-          </a:xfrm>
-          <a:prstGeom prst="ellipse">
+            <a:off x="384048" y="740600"/>
+            <a:ext cx="6793992" cy="590626"/>
+          </a:xfrm>
+          <a:prstGeom prst="rect">
             <a:avLst/>
           </a:prstGeom>
           <a:solidFill>
             <a:srgbClr val="182D56"/>
           </a:solidFill>
-          <a:ln>
-            <a:noFill/>
+          <a:ln w="18000">
+            <a:solidFill>
+              <a:srgbClr val="C9A84C"/>
+            </a:solidFill>
           </a:ln>
         </p:spPr>
         <p:style>
@@ -9621,14 +9917,14 @@
       </p:sp>
       <p:sp>
         <p:nvSpPr>
-          <p:cNvPr id="4" name="TextBox 3"/>
+          <p:cNvPr id="6" name="TextBox 5"/>
           <p:cNvSpPr txBox="1"/>
           <p:nvPr/>
         </p:nvSpPr>
         <p:spPr>
           <a:xfrm>
-            <a:off x="384048" y="502920"/>
-            <a:ext cx="6793992" cy="548640"/>
+            <a:off x="474048" y="776979"/>
+            <a:ext cx="6613992" cy="160000"/>
           </a:xfrm>
           <a:prstGeom prst="rect">
             <a:avLst/>
@@ -9636,32 +9932,33 @@
           <a:noFill/>
         </p:spPr>
         <p:txBody>
-          <a:bodyPr wrap="square"/>
+          <a:bodyPr wrap="square" lIns="0" tIns="0" rIns="0" bIns="0">
+            <a:spAutoFit/>
+          </a:bodyPr>
           <a:lstStyle/>
           <a:p>
             <a:pPr algn="l"/>
             <a:r>
-              <a:rPr sz="3200" b="1" i="0">
-                <a:solidFill>
-                  <a:srgbClr val="FFFFFF"/>
-                </a:solidFill>
-                <a:latin typeface="Georgia"/>
-              </a:rPr>
-              <a:t>Proposta de Honorários</a:t>
-            </a:r>
-          </a:p>
-        </p:txBody>
-      </p:sp>
-      <p:sp>
-        <p:nvSpPr>
-          <p:cNvPr id="5" name="TextBox 4"/>
+              <a:rPr sz="800" b="1" i="0" dirty="0">
+                <a:solidFill>
+                  <a:srgbClr val="8899AA"/>
+                </a:solidFill>
+              </a:rPr>
+              <a:t>VALOR TOTAL DA CAUSA</a:t>
+            </a:r>
+          </a:p>
+        </p:txBody>
+      </p:sp>
+      <p:sp>
+        <p:nvSpPr>
+          <p:cNvPr id="7" name="TextBox 6"/>
           <p:cNvSpPr txBox="1"/>
           <p:nvPr/>
         </p:nvSpPr>
         <p:spPr>
           <a:xfrm>
-            <a:off x="384048" y="1078992"/>
-            <a:ext cx="6793992" cy="310896"/>
+            <a:off x="464048" y="871979"/>
+            <a:ext cx="6393992" cy="220000"/>
           </a:xfrm>
           <a:prstGeom prst="rect">
             <a:avLst/>
@@ -9669,38 +9966,39 @@
           <a:noFill/>
         </p:spPr>
         <p:txBody>
-          <a:bodyPr wrap="square"/>
+          <a:bodyPr wrap="square" lIns="0" tIns="0" rIns="0" bIns="0">
+            <a:spAutoFit/>
+          </a:bodyPr>
           <a:lstStyle/>
           <a:p>
             <a:pPr algn="l"/>
             <a:r>
-              <a:rPr sz="1300" b="0" i="0">
-                <a:solidFill>
-                  <a:srgbClr val="8899AA"/>
-                </a:solidFill>
-                <a:latin typeface="Calibri"/>
-              </a:rPr>
-              <a:t>Opções flexíveis adaptadas à sua realidade financeira.</a:t>
-            </a:r>
-          </a:p>
-        </p:txBody>
-      </p:sp>
-      <p:sp>
-        <p:nvSpPr>
-          <p:cNvPr id="6" name="Rectangle 5"/>
+              <a:rPr sz="2800" b="1" i="0" dirty="0">
+                <a:solidFill>
+                  <a:srgbClr val="C9A84C"/>
+                </a:solidFill>
+              </a:rPr>
+              <a:t>{{VALOR_CAUSA}}</a:t>
+            </a:r>
+          </a:p>
+        </p:txBody>
+      </p:sp>
+      <p:sp>
+        <p:nvSpPr>
+          <p:cNvPr id="9" name="Rectangle 8"/>
           <p:cNvSpPr/>
           <p:nvPr/>
         </p:nvSpPr>
         <p:spPr>
           <a:xfrm>
-            <a:off x="384048" y="1508760"/>
-            <a:ext cx="6793992" cy="27432"/>
+            <a:off x="384048" y="1340000"/>
+            <a:ext cx="6793992" cy="16000"/>
           </a:xfrm>
           <a:prstGeom prst="rect">
             <a:avLst/>
           </a:prstGeom>
           <a:solidFill>
-            <a:srgbClr val="1E3060"/>
+            <a:srgbClr val="2A4070"/>
           </a:solidFill>
           <a:ln>
             <a:noFill/>
@@ -9731,14 +10029,48 @@
       </p:sp>
       <p:sp>
         <p:nvSpPr>
-          <p:cNvPr id="7" name="Rectangle 6"/>
+          <p:cNvPr id="10" name="TextBox 9"/>
+          <p:cNvSpPr txBox="1"/>
+          <p:nvPr/>
+        </p:nvSpPr>
+        <p:spPr>
+          <a:xfrm>
+            <a:off x="384048" y="1419400"/>
+            <a:ext cx="6793992" cy="180000"/>
+          </a:xfrm>
+          <a:prstGeom prst="rect">
+            <a:avLst/>
+          </a:prstGeom>
+          <a:noFill/>
+        </p:spPr>
+        <p:txBody>
+          <a:bodyPr wrap="square" lIns="0" tIns="0" rIns="0" bIns="0">
+            <a:spAutoFit/>
+          </a:bodyPr>
+          <a:lstStyle/>
+          <a:p>
+            <a:pPr algn="ctr"/>
+            <a:r>
+              <a:rPr sz="900" b="1" i="0" dirty="0">
+                <a:solidFill>
+                  <a:srgbClr val="8899AA"/>
+                </a:solidFill>
+              </a:rPr>
+              <a:t>NOSSOS HONORÁRIOS</a:t>
+            </a:r>
+          </a:p>
+        </p:txBody>
+      </p:sp>
+      <p:sp>
+        <p:nvSpPr>
+          <p:cNvPr id="11" name="Rectangle 10"/>
           <p:cNvSpPr/>
           <p:nvPr/>
         </p:nvSpPr>
         <p:spPr>
           <a:xfrm>
-            <a:off x="384048" y="1719072"/>
-            <a:ext cx="6793992" cy="4069080"/>
+            <a:off x="384048" y="1580000"/>
+            <a:ext cx="3296996" cy="1106000"/>
           </a:xfrm>
           <a:prstGeom prst="rect">
             <a:avLst/>
@@ -9746,7 +10078,7 @@
           <a:solidFill>
             <a:srgbClr val="132447"/>
           </a:solidFill>
-          <a:ln w="6350">
+          <a:ln w="12000">
             <a:solidFill>
               <a:srgbClr val="1E3060"/>
             </a:solidFill>
@@ -9777,14 +10109,524 @@
       </p:sp>
       <p:sp>
         <p:nvSpPr>
-          <p:cNvPr id="8" name="Rectangle 7"/>
+          <p:cNvPr id="12" name="TextBox 11"/>
+          <p:cNvSpPr txBox="1"/>
+          <p:nvPr/>
+        </p:nvSpPr>
+        <p:spPr>
+          <a:xfrm>
+            <a:off x="464048" y="1660000"/>
+            <a:ext cx="3136996" cy="220000"/>
+          </a:xfrm>
+          <a:prstGeom prst="rect">
+            <a:avLst/>
+          </a:prstGeom>
+          <a:noFill/>
+        </p:spPr>
+        <p:txBody>
+          <a:bodyPr wrap="square" lIns="0" tIns="0" rIns="0" bIns="0">
+            <a:spAutoFit/>
+          </a:bodyPr>
+          <a:lstStyle/>
+          <a:p>
+            <a:pPr algn="l"/>
+            <a:r>
+              <a:rPr sz="800" b="1" i="0" dirty="0">
+                <a:solidFill>
+                  <a:srgbClr val="C9A84C"/>
+                </a:solidFill>
+              </a:rPr>
+              <a:t>OPÇÃO 01</a:t>
+            </a:r>
+          </a:p>
+          <a:p>
+            <a:pPr algn="l">
+              <a:spcBef>
+                <a:spcPts val="400"/>
+              </a:spcBef>
+            </a:pPr>
+            <a:r>
+              <a:rPr sz="1300" b="1" i="0" dirty="0" err="1">
+                <a:solidFill>
+                  <a:srgbClr val="FFFFFF"/>
+                </a:solidFill>
+              </a:rPr>
+              <a:t>Boleto</a:t>
+            </a:r>
+            <a:r>
+              <a:rPr sz="1300" b="1" i="0" dirty="0">
+                <a:solidFill>
+                  <a:srgbClr val="FFFFFF"/>
+                </a:solidFill>
+              </a:rPr>
+              <a:t> </a:t>
+            </a:r>
+            <a:r>
+              <a:rPr sz="1300" b="1" i="0" dirty="0" err="1">
+                <a:solidFill>
+                  <a:srgbClr val="FFFFFF"/>
+                </a:solidFill>
+              </a:rPr>
+              <a:t>Bancário</a:t>
+            </a:r>
+            <a:endParaRPr sz="1300" b="1" i="0" dirty="0">
+              <a:solidFill>
+                <a:srgbClr val="FFFFFF"/>
+              </a:solidFill>
+            </a:endParaRPr>
+          </a:p>
+        </p:txBody>
+      </p:sp>
+      <p:sp>
+        <p:nvSpPr>
+          <p:cNvPr id="13" name="TextBox 12"/>
+          <p:cNvSpPr txBox="1"/>
+          <p:nvPr/>
+        </p:nvSpPr>
+        <p:spPr>
+          <a:xfrm>
+            <a:off x="464048" y="1910000"/>
+            <a:ext cx="3136996" cy="380000"/>
+          </a:xfrm>
+          <a:prstGeom prst="rect">
+            <a:avLst/>
+          </a:prstGeom>
+          <a:noFill/>
+        </p:spPr>
+        <p:txBody>
+          <a:bodyPr wrap="square" lIns="0" tIns="0" rIns="0" bIns="0">
+            <a:spAutoFit/>
+          </a:bodyPr>
+          <a:lstStyle/>
+          <a:p>
+            <a:pPr algn="l"/>
+            <a:r>
+              <a:rPr sz="3600" b="1" i="0" dirty="0">
+                <a:solidFill>
+                  <a:srgbClr val="E5CC7A"/>
+                </a:solidFill>
+              </a:rPr>
+              <a:t>{{PERC_OP1}}</a:t>
+            </a:r>
+          </a:p>
+        </p:txBody>
+      </p:sp>
+      <p:sp>
+        <p:nvSpPr>
+          <p:cNvPr id="14" name="TextBox 13"/>
+          <p:cNvSpPr txBox="1"/>
+          <p:nvPr/>
+        </p:nvSpPr>
+        <p:spPr>
+          <a:xfrm>
+            <a:off x="464048" y="2376042"/>
+            <a:ext cx="3136996" cy="260000"/>
+          </a:xfrm>
+          <a:prstGeom prst="rect">
+            <a:avLst/>
+          </a:prstGeom>
+          <a:noFill/>
+        </p:spPr>
+        <p:txBody>
+          <a:bodyPr wrap="square" lIns="0" tIns="0" rIns="0" bIns="0">
+            <a:spAutoFit/>
+          </a:bodyPr>
+          <a:lstStyle/>
+          <a:p>
+            <a:pPr algn="l"/>
+            <a:r>
+              <a:rPr sz="900" b="0" i="0" dirty="0">
+                <a:solidFill>
+                  <a:srgbClr val="8899AA"/>
+                </a:solidFill>
+              </a:rPr>
+              <a:t>do valor total da causa</a:t>
+            </a:r>
+          </a:p>
+          <a:p>
+            <a:pPr algn="l">
+              <a:spcBef>
+                <a:spcPts val="300"/>
+              </a:spcBef>
+            </a:pPr>
+            <a:r>
+              <a:rPr sz="800" b="0" i="1" dirty="0" err="1">
+                <a:solidFill>
+                  <a:srgbClr val="8899AA"/>
+                </a:solidFill>
+              </a:rPr>
+              <a:t>Parcelado</a:t>
+            </a:r>
+            <a:r>
+              <a:rPr sz="800" b="0" i="1" dirty="0">
+                <a:solidFill>
+                  <a:srgbClr val="8899AA"/>
+                </a:solidFill>
+              </a:rPr>
+              <a:t> com entrada</a:t>
+            </a:r>
+          </a:p>
+        </p:txBody>
+      </p:sp>
+      <p:sp>
+        <p:nvSpPr>
+          <p:cNvPr id="15" name="Rectangle 14"/>
           <p:cNvSpPr/>
           <p:nvPr/>
         </p:nvSpPr>
         <p:spPr>
           <a:xfrm>
-            <a:off x="384048" y="1719072"/>
-            <a:ext cx="50292" cy="4069080"/>
+            <a:off x="3881044" y="1580000"/>
+            <a:ext cx="3296996" cy="1096000"/>
+          </a:xfrm>
+          <a:prstGeom prst="rect">
+            <a:avLst/>
+          </a:prstGeom>
+          <a:solidFill>
+            <a:srgbClr val="132447"/>
+          </a:solidFill>
+          <a:ln w="12000">
+            <a:solidFill>
+              <a:srgbClr val="1E3060"/>
+            </a:solidFill>
+          </a:ln>
+        </p:spPr>
+        <p:style>
+          <a:lnRef idx="1">
+            <a:schemeClr val="accent1"/>
+          </a:lnRef>
+          <a:fillRef idx="3">
+            <a:schemeClr val="accent1"/>
+          </a:fillRef>
+          <a:effectRef idx="2">
+            <a:schemeClr val="accent1"/>
+          </a:effectRef>
+          <a:fontRef idx="minor">
+            <a:schemeClr val="lt1"/>
+          </a:fontRef>
+        </p:style>
+        <p:txBody>
+          <a:bodyPr rtlCol="0" anchor="ctr"/>
+          <a:lstStyle/>
+          <a:p>
+            <a:pPr algn="ctr"/>
+            <a:endParaRPr/>
+          </a:p>
+        </p:txBody>
+      </p:sp>
+      <p:sp>
+        <p:nvSpPr>
+          <p:cNvPr id="16" name="TextBox 15"/>
+          <p:cNvSpPr txBox="1"/>
+          <p:nvPr/>
+        </p:nvSpPr>
+        <p:spPr>
+          <a:xfrm>
+            <a:off x="3961044" y="1660000"/>
+            <a:ext cx="3136996" cy="220000"/>
+          </a:xfrm>
+          <a:prstGeom prst="rect">
+            <a:avLst/>
+          </a:prstGeom>
+          <a:noFill/>
+        </p:spPr>
+        <p:txBody>
+          <a:bodyPr wrap="square" lIns="0" tIns="0" rIns="0" bIns="0">
+            <a:spAutoFit/>
+          </a:bodyPr>
+          <a:lstStyle/>
+          <a:p>
+            <a:pPr algn="l"/>
+            <a:r>
+              <a:rPr sz="800" b="1" i="0">
+                <a:solidFill>
+                  <a:srgbClr val="C9A84C"/>
+                </a:solidFill>
+              </a:rPr>
+              <a:t>OPÇÃO 02</a:t>
+            </a:r>
+          </a:p>
+          <a:p>
+            <a:pPr algn="l">
+              <a:spcBef>
+                <a:spcPts val="400"/>
+              </a:spcBef>
+            </a:pPr>
+            <a:r>
+              <a:rPr sz="1300" b="1" i="0">
+                <a:solidFill>
+                  <a:srgbClr val="FFFFFF"/>
+                </a:solidFill>
+              </a:rPr>
+              <a:t>Cartão de Crédito</a:t>
+            </a:r>
+          </a:p>
+        </p:txBody>
+      </p:sp>
+      <p:sp>
+        <p:nvSpPr>
+          <p:cNvPr id="17" name="TextBox 16"/>
+          <p:cNvSpPr txBox="1"/>
+          <p:nvPr/>
+        </p:nvSpPr>
+        <p:spPr>
+          <a:xfrm>
+            <a:off x="3961044" y="1910000"/>
+            <a:ext cx="3136996" cy="380000"/>
+          </a:xfrm>
+          <a:prstGeom prst="rect">
+            <a:avLst/>
+          </a:prstGeom>
+          <a:noFill/>
+        </p:spPr>
+        <p:txBody>
+          <a:bodyPr wrap="square" lIns="0" tIns="0" rIns="0" bIns="0">
+            <a:spAutoFit/>
+          </a:bodyPr>
+          <a:lstStyle/>
+          <a:p>
+            <a:pPr algn="l"/>
+            <a:r>
+              <a:rPr sz="3600" b="1" i="0" dirty="0">
+                <a:solidFill>
+                  <a:srgbClr val="E5CC7A"/>
+                </a:solidFill>
+              </a:rPr>
+              <a:t>{{PERC_OP2_AV}}</a:t>
+            </a:r>
+          </a:p>
+        </p:txBody>
+      </p:sp>
+      <p:sp>
+        <p:nvSpPr>
+          <p:cNvPr id="18" name="TextBox 17"/>
+          <p:cNvSpPr txBox="1"/>
+          <p:nvPr/>
+        </p:nvSpPr>
+        <p:spPr>
+          <a:xfrm>
+            <a:off x="3976044" y="2363612"/>
+            <a:ext cx="3136996" cy="260000"/>
+          </a:xfrm>
+          <a:prstGeom prst="rect">
+            <a:avLst/>
+          </a:prstGeom>
+          <a:noFill/>
+        </p:spPr>
+        <p:txBody>
+          <a:bodyPr wrap="square" lIns="0" tIns="0" rIns="0" bIns="0">
+            <a:spAutoFit/>
+          </a:bodyPr>
+          <a:lstStyle/>
+          <a:p>
+            <a:pPr algn="l"/>
+            <a:r>
+              <a:rPr sz="900" b="0" i="0" dirty="0">
+                <a:solidFill>
+                  <a:srgbClr val="8899AA"/>
+                </a:solidFill>
+              </a:rPr>
+              <a:t>do valor total da causa</a:t>
+            </a:r>
+          </a:p>
+          <a:p>
+            <a:pPr algn="l">
+              <a:spcBef>
+                <a:spcPts val="300"/>
+              </a:spcBef>
+            </a:pPr>
+            <a:r>
+              <a:rPr sz="800" b="0" i="1" dirty="0">
+                <a:solidFill>
+                  <a:srgbClr val="8899AA"/>
+                </a:solidFill>
+              </a:rPr>
+              <a:t>À vista no </a:t>
+            </a:r>
+            <a:r>
+              <a:rPr sz="800" b="0" i="1" dirty="0" err="1">
+                <a:solidFill>
+                  <a:srgbClr val="8899AA"/>
+                </a:solidFill>
+              </a:rPr>
+              <a:t>cartão</a:t>
+            </a:r>
+            <a:r>
+              <a:rPr sz="800" b="0" i="1" dirty="0">
+                <a:solidFill>
+                  <a:srgbClr val="8899AA"/>
+                </a:solidFill>
+              </a:rPr>
+              <a:t>, </a:t>
+            </a:r>
+            <a:r>
+              <a:rPr sz="800" b="0" i="1" dirty="0" err="1">
+                <a:solidFill>
+                  <a:srgbClr val="8899AA"/>
+                </a:solidFill>
+              </a:rPr>
+              <a:t>parcelado</a:t>
+            </a:r>
+            <a:r>
+              <a:rPr sz="800" b="0" i="1" dirty="0">
+                <a:solidFill>
+                  <a:srgbClr val="8899AA"/>
+                </a:solidFill>
+              </a:rPr>
+              <a:t> </a:t>
+            </a:r>
+            <a:r>
+              <a:rPr sz="800" b="0" i="1" dirty="0" err="1">
+                <a:solidFill>
+                  <a:srgbClr val="8899AA"/>
+                </a:solidFill>
+              </a:rPr>
+              <a:t>sem</a:t>
+            </a:r>
+            <a:r>
+              <a:rPr sz="800" b="0" i="1" dirty="0">
+                <a:solidFill>
+                  <a:srgbClr val="8899AA"/>
+                </a:solidFill>
+              </a:rPr>
+              <a:t> </a:t>
+            </a:r>
+            <a:r>
+              <a:rPr sz="800" b="0" i="1" dirty="0" err="1">
+                <a:solidFill>
+                  <a:srgbClr val="8899AA"/>
+                </a:solidFill>
+              </a:rPr>
+              <a:t>juros</a:t>
+            </a:r>
+            <a:endParaRPr sz="800" b="0" i="1" dirty="0">
+              <a:solidFill>
+                <a:srgbClr val="8899AA"/>
+              </a:solidFill>
+            </a:endParaRPr>
+          </a:p>
+        </p:txBody>
+      </p:sp>
+      <p:sp>
+        <p:nvSpPr>
+          <p:cNvPr id="19" name="Rectangle 18"/>
+          <p:cNvSpPr/>
+          <p:nvPr/>
+        </p:nvSpPr>
+        <p:spPr>
+          <a:xfrm>
+            <a:off x="384048" y="2740000"/>
+            <a:ext cx="6793992" cy="16000"/>
+          </a:xfrm>
+          <a:prstGeom prst="rect">
+            <a:avLst/>
+          </a:prstGeom>
+          <a:solidFill>
+            <a:srgbClr val="2A4070"/>
+          </a:solidFill>
+          <a:ln>
+            <a:noFill/>
+          </a:ln>
+        </p:spPr>
+        <p:style>
+          <a:lnRef idx="1">
+            <a:schemeClr val="accent1"/>
+          </a:lnRef>
+          <a:fillRef idx="3">
+            <a:schemeClr val="accent1"/>
+          </a:fillRef>
+          <a:effectRef idx="2">
+            <a:schemeClr val="accent1"/>
+          </a:effectRef>
+          <a:fontRef idx="minor">
+            <a:schemeClr val="lt1"/>
+          </a:fontRef>
+        </p:style>
+        <p:txBody>
+          <a:bodyPr rtlCol="0" anchor="ctr"/>
+          <a:lstStyle/>
+          <a:p>
+            <a:pPr algn="ctr"/>
+            <a:endParaRPr/>
+          </a:p>
+        </p:txBody>
+      </p:sp>
+      <p:sp>
+        <p:nvSpPr>
+          <p:cNvPr id="20" name="TextBox 19"/>
+          <p:cNvSpPr txBox="1"/>
+          <p:nvPr/>
+        </p:nvSpPr>
+        <p:spPr>
+          <a:xfrm>
+            <a:off x="384048" y="2820000"/>
+            <a:ext cx="6793992" cy="261610"/>
+          </a:xfrm>
+          <a:prstGeom prst="rect">
+            <a:avLst/>
+          </a:prstGeom>
+          <a:noFill/>
+        </p:spPr>
+        <p:txBody>
+          <a:bodyPr wrap="square" lIns="0" tIns="0" rIns="0" bIns="0">
+            <a:spAutoFit/>
+          </a:bodyPr>
+          <a:lstStyle/>
+          <a:p>
+            <a:pPr algn="l"/>
+            <a:r>
+              <a:rPr sz="1700" b="1" i="0" dirty="0">
+                <a:solidFill>
+                  <a:srgbClr val="FFFFFF"/>
+                </a:solidFill>
+              </a:rPr>
+              <a:t>Por </a:t>
+            </a:r>
+            <a:r>
+              <a:rPr sz="1700" b="1" i="0" dirty="0" err="1">
+                <a:solidFill>
+                  <a:srgbClr val="FFFFFF"/>
+                </a:solidFill>
+              </a:rPr>
+              <a:t>que</a:t>
+            </a:r>
+            <a:r>
+              <a:rPr sz="1700" b="1" i="0" dirty="0">
+                <a:solidFill>
+                  <a:srgbClr val="FFFFFF"/>
+                </a:solidFill>
+              </a:rPr>
+              <a:t> a </a:t>
+            </a:r>
+            <a:r>
+              <a:rPr sz="1700" b="1" i="0" dirty="0" err="1">
+                <a:solidFill>
+                  <a:srgbClr val="FFFFFF"/>
+                </a:solidFill>
+              </a:rPr>
+              <a:t>BlindSafe</a:t>
+            </a:r>
+            <a:r>
+              <a:rPr sz="1700" b="1" i="0" dirty="0">
+                <a:solidFill>
+                  <a:srgbClr val="FFFFFF"/>
+                </a:solidFill>
+              </a:rPr>
+              <a:t>?</a:t>
+            </a:r>
+          </a:p>
+        </p:txBody>
+      </p:sp>
+      <p:sp>
+        <p:nvSpPr>
+          <p:cNvPr id="21" name="Rectangle 20"/>
+          <p:cNvSpPr/>
+          <p:nvPr/>
+        </p:nvSpPr>
+        <p:spPr>
+          <a:xfrm>
+            <a:off x="384048" y="3130000"/>
+            <a:ext cx="300000" cy="300000"/>
           </a:xfrm>
           <a:prstGeom prst="rect">
             <a:avLst/>
@@ -9819,40 +10661,16 @@
           </a:p>
         </p:txBody>
       </p:sp>
-      <p:pic>
-        <p:nvPicPr>
-          <p:cNvPr id="9" name="Picture 8" descr="image5.png"/>
-          <p:cNvPicPr>
-            <a:picLocks noChangeAspect="1"/>
-          </p:cNvPicPr>
-          <p:nvPr/>
-        </p:nvPicPr>
-        <p:blipFill>
-          <a:blip r:embed="rId2"/>
-          <a:stretch>
-            <a:fillRect/>
-          </a:stretch>
-        </p:blipFill>
-        <p:spPr>
-          <a:xfrm>
-            <a:off x="6053328" y="1920240"/>
-            <a:ext cx="411480" cy="411480"/>
-          </a:xfrm>
-          <a:prstGeom prst="rect">
-            <a:avLst/>
-          </a:prstGeom>
-        </p:spPr>
-      </p:pic>
-      <p:sp>
-        <p:nvSpPr>
-          <p:cNvPr id="10" name="TextBox 9"/>
+      <p:sp>
+        <p:nvSpPr>
+          <p:cNvPr id="22" name="TextBox 21"/>
           <p:cNvSpPr txBox="1"/>
           <p:nvPr/>
         </p:nvSpPr>
         <p:spPr>
           <a:xfrm>
-            <a:off x="621792" y="1920240"/>
-            <a:ext cx="2743200" cy="256032"/>
+            <a:off x="384048" y="3160000"/>
+            <a:ext cx="300000" cy="270000"/>
           </a:xfrm>
           <a:prstGeom prst="rect">
             <a:avLst/>
@@ -9860,568 +10678,23 @@
           <a:noFill/>
         </p:spPr>
         <p:txBody>
-          <a:bodyPr wrap="square"/>
-          <a:lstStyle/>
-          <a:p>
-            <a:pPr algn="l"/>
-            <a:r>
-              <a:rPr sz="1400" b="1" i="0" spc="200" dirty="0">
-                <a:solidFill>
-                  <a:srgbClr val="C9A84C"/>
-                </a:solidFill>
-                <a:latin typeface="Calibri"/>
-              </a:rPr>
-              <a:t>OPÇÃO 01</a:t>
-            </a:r>
-          </a:p>
-        </p:txBody>
-      </p:sp>
-      <p:sp>
-        <p:nvSpPr>
-          <p:cNvPr id="11" name="TextBox 10"/>
-          <p:cNvSpPr txBox="1"/>
-          <p:nvPr/>
-        </p:nvSpPr>
-        <p:spPr>
-          <a:xfrm>
-            <a:off x="621792" y="2249424"/>
-            <a:ext cx="6400800" cy="402336"/>
-          </a:xfrm>
-          <a:prstGeom prst="rect">
-            <a:avLst/>
-          </a:prstGeom>
-          <a:noFill/>
-        </p:spPr>
-        <p:txBody>
-          <a:bodyPr wrap="square"/>
-          <a:lstStyle/>
-          <a:p>
-            <a:pPr algn="l"/>
-            <a:r>
-              <a:rPr sz="2000" b="1" i="0" dirty="0" err="1">
-                <a:solidFill>
-                  <a:srgbClr val="FFFFFF"/>
-                </a:solidFill>
-                <a:latin typeface="Georgia"/>
-              </a:rPr>
-              <a:t>Parcelamento</a:t>
-            </a:r>
-            <a:r>
-              <a:rPr sz="2000" b="1" i="0" dirty="0">
-                <a:solidFill>
-                  <a:srgbClr val="FFFFFF"/>
-                </a:solidFill>
-                <a:latin typeface="Georgia"/>
-              </a:rPr>
-              <a:t> via </a:t>
-            </a:r>
-            <a:r>
-              <a:rPr sz="2000" b="1" i="0" dirty="0" err="1">
-                <a:solidFill>
-                  <a:srgbClr val="FFFFFF"/>
-                </a:solidFill>
-                <a:latin typeface="Georgia"/>
-              </a:rPr>
-              <a:t>Boleto</a:t>
-            </a:r>
-            <a:r>
-              <a:rPr sz="2000" b="1" i="0" dirty="0">
-                <a:solidFill>
-                  <a:srgbClr val="FFFFFF"/>
-                </a:solidFill>
-                <a:latin typeface="Georgia"/>
-              </a:rPr>
-              <a:t> Bancário</a:t>
-            </a:r>
-          </a:p>
-        </p:txBody>
-      </p:sp>
-      <p:sp>
-        <p:nvSpPr>
-          <p:cNvPr id="12" name="Rectangle 11"/>
-          <p:cNvSpPr/>
-          <p:nvPr/>
-        </p:nvSpPr>
-        <p:spPr>
-          <a:xfrm>
-            <a:off x="621792" y="2798063"/>
-            <a:ext cx="6400800" cy="27432"/>
-          </a:xfrm>
-          <a:prstGeom prst="rect">
-            <a:avLst/>
-          </a:prstGeom>
-          <a:solidFill>
-            <a:srgbClr val="2A4070"/>
-          </a:solidFill>
-          <a:ln>
-            <a:noFill/>
-          </a:ln>
-        </p:spPr>
-        <p:style>
-          <a:lnRef idx="1">
-            <a:schemeClr val="accent1"/>
-          </a:lnRef>
-          <a:fillRef idx="3">
-            <a:schemeClr val="accent1"/>
-          </a:fillRef>
-          <a:effectRef idx="2">
-            <a:schemeClr val="accent1"/>
-          </a:effectRef>
-          <a:fontRef idx="minor">
-            <a:schemeClr val="lt1"/>
-          </a:fontRef>
-        </p:style>
-        <p:txBody>
-          <a:bodyPr rtlCol="0" anchor="ctr"/>
+          <a:bodyPr wrap="square" lIns="0" tIns="0" rIns="0" bIns="0">
+            <a:spAutoFit/>
+          </a:bodyPr>
           <a:lstStyle/>
           <a:p>
             <a:pPr algn="ctr"/>
-            <a:endParaRPr/>
-          </a:p>
-        </p:txBody>
-      </p:sp>
-      <p:sp>
-        <p:nvSpPr>
-          <p:cNvPr id="13" name="TextBox 12"/>
-          <p:cNvSpPr txBox="1"/>
-          <p:nvPr/>
-        </p:nvSpPr>
-        <p:spPr>
-          <a:xfrm>
-            <a:off x="621792" y="2999232"/>
-            <a:ext cx="2194560" cy="228600"/>
-          </a:xfrm>
-          <a:prstGeom prst="rect">
-            <a:avLst/>
-          </a:prstGeom>
-          <a:noFill/>
-        </p:spPr>
-        <p:txBody>
-          <a:bodyPr wrap="square"/>
-          <a:lstStyle/>
-          <a:p>
-            <a:pPr algn="l"/>
-            <a:r>
-              <a:rPr sz="1200" b="1" i="0" spc="100" dirty="0">
-                <a:solidFill>
-                  <a:srgbClr val="C9A84C"/>
-                </a:solidFill>
-                <a:latin typeface="Calibri"/>
-              </a:rPr>
-              <a:t>VALOR TOTAL</a:t>
-            </a:r>
-          </a:p>
-        </p:txBody>
-      </p:sp>
-      <p:sp>
-        <p:nvSpPr>
-          <p:cNvPr id="14" name="TextBox 13"/>
-          <p:cNvSpPr txBox="1"/>
-          <p:nvPr/>
-        </p:nvSpPr>
-        <p:spPr>
-          <a:xfrm>
-            <a:off x="621792" y="3255263"/>
-            <a:ext cx="2194560" cy="475488"/>
-          </a:xfrm>
-          <a:prstGeom prst="rect">
-            <a:avLst/>
-          </a:prstGeom>
-          <a:noFill/>
-        </p:spPr>
-        <p:txBody>
-          <a:bodyPr wrap="square"/>
-          <a:lstStyle/>
-          <a:p>
-            <a:pPr algn="l"/>
-            <a:r>
-              <a:rPr sz="2000" b="1" i="0" dirty="0">
-                <a:solidFill>
-                  <a:srgbClr val="FFFFFF"/>
-                </a:solidFill>
-                <a:latin typeface="Calibri"/>
-              </a:rPr>
-              <a:t>{{OP1_VALOR_TOTAL}}</a:t>
-            </a:r>
-          </a:p>
-        </p:txBody>
-      </p:sp>
-      <p:sp>
-        <p:nvSpPr>
-          <p:cNvPr id="15" name="TextBox 14"/>
-          <p:cNvSpPr txBox="1"/>
-          <p:nvPr/>
-        </p:nvSpPr>
-        <p:spPr>
-          <a:xfrm>
-            <a:off x="2743200" y="2999232"/>
-            <a:ext cx="2194560" cy="228600"/>
-          </a:xfrm>
-          <a:prstGeom prst="rect">
-            <a:avLst/>
-          </a:prstGeom>
-          <a:noFill/>
-        </p:spPr>
-        <p:txBody>
-          <a:bodyPr wrap="square"/>
-          <a:lstStyle/>
-          <a:p>
-            <a:pPr algn="l"/>
-            <a:r>
-              <a:rPr sz="1200" b="1" i="0" spc="100" dirty="0">
-                <a:solidFill>
-                  <a:srgbClr val="C9A84C"/>
-                </a:solidFill>
-                <a:latin typeface="Calibri"/>
-              </a:rPr>
-              <a:t>ENTRADA</a:t>
-            </a:r>
-          </a:p>
-        </p:txBody>
-      </p:sp>
-      <p:sp>
-        <p:nvSpPr>
-          <p:cNvPr id="16" name="TextBox 15"/>
-          <p:cNvSpPr txBox="1"/>
-          <p:nvPr/>
-        </p:nvSpPr>
-        <p:spPr>
-          <a:xfrm>
-            <a:off x="2743200" y="3255263"/>
-            <a:ext cx="2194560" cy="475488"/>
-          </a:xfrm>
-          <a:prstGeom prst="rect">
-            <a:avLst/>
-          </a:prstGeom>
-          <a:noFill/>
-        </p:spPr>
-        <p:txBody>
-          <a:bodyPr wrap="square"/>
-          <a:lstStyle/>
-          <a:p>
-            <a:pPr algn="l"/>
-            <a:r>
-              <a:rPr sz="2000" b="1" i="0" dirty="0">
-                <a:solidFill>
-                  <a:srgbClr val="FFFFFF"/>
-                </a:solidFill>
-                <a:latin typeface="Calibri"/>
-              </a:rPr>
-              <a:t>{{OP1_ENTRADA}}</a:t>
-            </a:r>
-          </a:p>
-        </p:txBody>
-      </p:sp>
-      <p:sp>
-        <p:nvSpPr>
-          <p:cNvPr id="17" name="TextBox 16"/>
-          <p:cNvSpPr txBox="1"/>
-          <p:nvPr/>
-        </p:nvSpPr>
-        <p:spPr>
-          <a:xfrm>
-            <a:off x="4892040" y="2999232"/>
-            <a:ext cx="2194560" cy="228600"/>
-          </a:xfrm>
-          <a:prstGeom prst="rect">
-            <a:avLst/>
-          </a:prstGeom>
-          <a:noFill/>
-        </p:spPr>
-        <p:txBody>
-          <a:bodyPr wrap="square"/>
-          <a:lstStyle/>
-          <a:p>
-            <a:pPr algn="l"/>
-            <a:r>
-              <a:rPr sz="1200" b="1" i="0" spc="100" dirty="0">
-                <a:solidFill>
-                  <a:srgbClr val="C9A84C"/>
-                </a:solidFill>
-                <a:latin typeface="Calibri"/>
-              </a:rPr>
-              <a:t>PARCELAS</a:t>
-            </a:r>
-          </a:p>
-        </p:txBody>
-      </p:sp>
-      <p:sp>
-        <p:nvSpPr>
-          <p:cNvPr id="18" name="TextBox 17"/>
-          <p:cNvSpPr txBox="1"/>
-          <p:nvPr/>
-        </p:nvSpPr>
-        <p:spPr>
-          <a:xfrm>
-            <a:off x="4892040" y="3255263"/>
-            <a:ext cx="2194560" cy="475488"/>
-          </a:xfrm>
-          <a:prstGeom prst="rect">
-            <a:avLst/>
-          </a:prstGeom>
-          <a:noFill/>
-        </p:spPr>
-        <p:txBody>
-          <a:bodyPr wrap="square"/>
-          <a:lstStyle/>
-          <a:p>
-            <a:pPr algn="l"/>
-            <a:r>
-              <a:rPr sz="2000" b="1" i="0" dirty="0">
-                <a:solidFill>
-                  <a:srgbClr val="FFFFFF"/>
-                </a:solidFill>
-                <a:latin typeface="Calibri"/>
-              </a:rPr>
-              <a:t>{{OP1_PARCELAS}}</a:t>
-            </a:r>
-          </a:p>
-        </p:txBody>
-      </p:sp>
-      <p:sp>
-        <p:nvSpPr>
-          <p:cNvPr id="19" name="Rectangle 18"/>
-          <p:cNvSpPr/>
-          <p:nvPr/>
-        </p:nvSpPr>
-        <p:spPr>
-          <a:xfrm>
-            <a:off x="621792" y="3959352"/>
-            <a:ext cx="6400800" cy="27432"/>
-          </a:xfrm>
-          <a:prstGeom prst="rect">
-            <a:avLst/>
-          </a:prstGeom>
-          <a:solidFill>
-            <a:srgbClr val="2A4070"/>
-          </a:solidFill>
-          <a:ln>
-            <a:noFill/>
-          </a:ln>
-        </p:spPr>
-        <p:style>
-          <a:lnRef idx="1">
-            <a:schemeClr val="accent1"/>
-          </a:lnRef>
-          <a:fillRef idx="3">
-            <a:schemeClr val="accent1"/>
-          </a:fillRef>
-          <a:effectRef idx="2">
-            <a:schemeClr val="accent1"/>
-          </a:effectRef>
-          <a:fontRef idx="minor">
-            <a:schemeClr val="lt1"/>
-          </a:fontRef>
-        </p:style>
-        <p:txBody>
-          <a:bodyPr rtlCol="0" anchor="ctr"/>
-          <a:lstStyle/>
-          <a:p>
-            <a:pPr algn="ctr"/>
-            <a:endParaRPr/>
-          </a:p>
-        </p:txBody>
-      </p:sp>
-      <p:sp>
-        <p:nvSpPr>
-          <p:cNvPr id="20" name="TextBox 19"/>
-          <p:cNvSpPr txBox="1"/>
-          <p:nvPr/>
-        </p:nvSpPr>
-        <p:spPr>
-          <a:xfrm>
-            <a:off x="621792" y="4096512"/>
-            <a:ext cx="6400800" cy="502920"/>
-          </a:xfrm>
-          <a:prstGeom prst="rect">
-            <a:avLst/>
-          </a:prstGeom>
-          <a:noFill/>
-        </p:spPr>
-        <p:txBody>
-          <a:bodyPr wrap="square"/>
-          <a:lstStyle/>
-          <a:p>
-            <a:pPr algn="l"/>
-            <a:r>
-              <a:rPr sz="1600" b="0" i="0" dirty="0" err="1">
-                <a:solidFill>
-                  <a:srgbClr val="8899AA"/>
-                </a:solidFill>
-                <a:latin typeface="Calibri"/>
-              </a:rPr>
-              <a:t>Honorários</a:t>
-            </a:r>
-            <a:r>
-              <a:rPr sz="1600" b="0" i="0" dirty="0">
-                <a:solidFill>
-                  <a:srgbClr val="8899AA"/>
-                </a:solidFill>
-                <a:latin typeface="Calibri"/>
-              </a:rPr>
-              <a:t> para </a:t>
-            </a:r>
-            <a:r>
-              <a:rPr sz="1600" b="0" i="0" dirty="0" err="1">
-                <a:solidFill>
-                  <a:srgbClr val="8899AA"/>
-                </a:solidFill>
-                <a:latin typeface="Calibri"/>
-              </a:rPr>
-              <a:t>início</a:t>
-            </a:r>
-            <a:r>
-              <a:rPr sz="1600" b="0" i="0" dirty="0">
-                <a:solidFill>
-                  <a:srgbClr val="8899AA"/>
-                </a:solidFill>
-                <a:latin typeface="Calibri"/>
-              </a:rPr>
-              <a:t> </a:t>
-            </a:r>
-            <a:r>
-              <a:rPr sz="1600" b="0" i="0" dirty="0" err="1">
-                <a:solidFill>
-                  <a:srgbClr val="8899AA"/>
-                </a:solidFill>
-                <a:latin typeface="Calibri"/>
-              </a:rPr>
-              <a:t>imediato</a:t>
-            </a:r>
-            <a:r>
-              <a:rPr sz="1600" b="0" i="0" dirty="0">
-                <a:solidFill>
-                  <a:srgbClr val="8899AA"/>
-                </a:solidFill>
-                <a:latin typeface="Calibri"/>
-              </a:rPr>
-              <a:t> dos </a:t>
-            </a:r>
-            <a:r>
-              <a:rPr sz="1600" b="0" i="0" dirty="0" err="1">
-                <a:solidFill>
-                  <a:srgbClr val="8899AA"/>
-                </a:solidFill>
-                <a:latin typeface="Calibri"/>
-              </a:rPr>
-              <a:t>trabalhos</a:t>
-            </a:r>
-            <a:r>
-              <a:rPr sz="1600" b="0" i="0" dirty="0">
-                <a:solidFill>
-                  <a:srgbClr val="8899AA"/>
-                </a:solidFill>
-                <a:latin typeface="Calibri"/>
-              </a:rPr>
-              <a:t> via </a:t>
-            </a:r>
-            <a:r>
-              <a:rPr sz="1600" b="0" i="0" dirty="0" err="1">
-                <a:solidFill>
-                  <a:srgbClr val="8899AA"/>
-                </a:solidFill>
-                <a:latin typeface="Calibri"/>
-              </a:rPr>
-              <a:t>boleto</a:t>
-            </a:r>
-            <a:r>
-              <a:rPr sz="1600" b="0" i="0" dirty="0">
-                <a:solidFill>
-                  <a:srgbClr val="8899AA"/>
-                </a:solidFill>
-                <a:latin typeface="Calibri"/>
-              </a:rPr>
-              <a:t> </a:t>
-            </a:r>
-            <a:r>
-              <a:rPr sz="1600" b="0" i="0" dirty="0" err="1">
-                <a:solidFill>
-                  <a:srgbClr val="8899AA"/>
-                </a:solidFill>
-                <a:latin typeface="Calibri"/>
-              </a:rPr>
-              <a:t>bancário</a:t>
-            </a:r>
-            <a:r>
-              <a:rPr sz="1600" b="0" i="0" dirty="0">
-                <a:solidFill>
-                  <a:srgbClr val="8899AA"/>
-                </a:solidFill>
-                <a:latin typeface="Calibri"/>
-              </a:rPr>
-              <a:t> mensal.</a:t>
-            </a:r>
-          </a:p>
-        </p:txBody>
-      </p:sp>
-      <p:sp>
-        <p:nvSpPr>
-          <p:cNvPr id="21" name="Rectangle 20"/>
-          <p:cNvSpPr/>
-          <p:nvPr/>
-        </p:nvSpPr>
-        <p:spPr>
-          <a:xfrm>
-            <a:off x="621792" y="4846320"/>
-            <a:ext cx="6400800" cy="27432"/>
-          </a:xfrm>
-          <a:prstGeom prst="rect">
-            <a:avLst/>
-          </a:prstGeom>
-          <a:solidFill>
-            <a:srgbClr val="2A4070"/>
-          </a:solidFill>
-          <a:ln>
-            <a:noFill/>
-          </a:ln>
-        </p:spPr>
-        <p:style>
-          <a:lnRef idx="1">
-            <a:schemeClr val="accent1"/>
-          </a:lnRef>
-          <a:fillRef idx="3">
-            <a:schemeClr val="accent1"/>
-          </a:fillRef>
-          <a:effectRef idx="2">
-            <a:schemeClr val="accent1"/>
-          </a:effectRef>
-          <a:fontRef idx="minor">
-            <a:schemeClr val="lt1"/>
-          </a:fontRef>
-        </p:style>
-        <p:txBody>
-          <a:bodyPr rtlCol="0" anchor="ctr"/>
-          <a:lstStyle/>
-          <a:p>
-            <a:pPr algn="ctr"/>
-            <a:endParaRPr/>
-          </a:p>
-        </p:txBody>
-      </p:sp>
-      <p:pic>
-        <p:nvPicPr>
-          <p:cNvPr id="22" name="Picture 21" descr="image5.png"/>
-          <p:cNvPicPr>
-            <a:picLocks noChangeAspect="1"/>
-          </p:cNvPicPr>
-          <p:nvPr/>
-        </p:nvPicPr>
-        <p:blipFill>
-          <a:blip r:embed="rId2"/>
-          <a:stretch>
-            <a:fillRect/>
-          </a:stretch>
-        </p:blipFill>
-        <p:spPr>
-          <a:xfrm>
-            <a:off x="621792" y="5010912"/>
-            <a:ext cx="292608" cy="292608"/>
-          </a:xfrm>
-          <a:prstGeom prst="rect">
-            <a:avLst/>
-          </a:prstGeom>
-        </p:spPr>
-      </p:pic>
+            <a:r>
+              <a:rPr sz="1800" b="1" i="0">
+                <a:solidFill>
+                  <a:srgbClr val="182D56"/>
+                </a:solidFill>
+              </a:rPr>
+              <a:t>01</a:t>
+            </a:r>
+          </a:p>
+        </p:txBody>
+      </p:sp>
       <p:sp>
         <p:nvSpPr>
           <p:cNvPr id="23" name="TextBox 22"/>
@@ -10430,8 +10703,8 @@
         </p:nvSpPr>
         <p:spPr>
           <a:xfrm>
-            <a:off x="1033272" y="4992624"/>
-            <a:ext cx="2834640" cy="548640"/>
+            <a:off x="762446" y="3160000"/>
+            <a:ext cx="6403992" cy="1343958"/>
           </a:xfrm>
           <a:prstGeom prst="rect">
             <a:avLst/>
@@ -10439,25 +10712,143 @@
           <a:noFill/>
         </p:spPr>
         <p:txBody>
-          <a:bodyPr wrap="square"/>
+          <a:bodyPr wrap="square" lIns="0" tIns="0" rIns="0" bIns="0">
+            <a:spAutoFit/>
+          </a:bodyPr>
           <a:lstStyle/>
           <a:p>
             <a:pPr algn="l"/>
             <a:r>
+              <a:rPr b="1" i="0" dirty="0" err="1">
+                <a:solidFill>
+                  <a:srgbClr val="FFFFFF"/>
+                </a:solidFill>
+              </a:rPr>
+              <a:t>Honorários</a:t>
+            </a:r>
+            <a:r>
+              <a:rPr b="1" i="0" dirty="0">
+                <a:solidFill>
+                  <a:srgbClr val="FFFFFF"/>
+                </a:solidFill>
+              </a:rPr>
+              <a:t> </a:t>
+            </a:r>
+            <a:r>
+              <a:rPr b="1" i="0" dirty="0" err="1">
+                <a:solidFill>
+                  <a:srgbClr val="FFFFFF"/>
+                </a:solidFill>
+              </a:rPr>
+              <a:t>abaixo</a:t>
+            </a:r>
+            <a:r>
+              <a:rPr b="1" i="0" dirty="0">
+                <a:solidFill>
+                  <a:srgbClr val="FFFFFF"/>
+                </a:solidFill>
+              </a:rPr>
+              <a:t> de 10%</a:t>
+            </a:r>
+          </a:p>
+          <a:p>
+            <a:pPr algn="l">
+              <a:spcBef>
+                <a:spcPts val="600"/>
+              </a:spcBef>
+            </a:pPr>
+            <a:r>
+              <a:rPr sz="1400" b="0" i="1" dirty="0" err="1">
+                <a:solidFill>
+                  <a:srgbClr val="E5CC7A"/>
+                </a:solidFill>
+              </a:rPr>
+              <a:t>Enquanto</a:t>
+            </a:r>
+            <a:r>
+              <a:rPr sz="1400" b="0" i="1" dirty="0">
+                <a:solidFill>
+                  <a:srgbClr val="E5CC7A"/>
+                </a:solidFill>
+              </a:rPr>
+              <a:t> outros </a:t>
+            </a:r>
+            <a:r>
+              <a:rPr sz="1400" b="0" i="1" dirty="0" err="1">
+                <a:solidFill>
+                  <a:srgbClr val="E5CC7A"/>
+                </a:solidFill>
+              </a:rPr>
+              <a:t>cobram</a:t>
+            </a:r>
+            <a:r>
+              <a:rPr sz="1400" b="0" i="1" dirty="0">
+                <a:solidFill>
+                  <a:srgbClr val="E5CC7A"/>
+                </a:solidFill>
+              </a:rPr>
+              <a:t> </a:t>
+            </a:r>
+            <a:r>
+              <a:rPr sz="1400" b="0" i="1" dirty="0" err="1">
+                <a:solidFill>
+                  <a:srgbClr val="E5CC7A"/>
+                </a:solidFill>
+              </a:rPr>
+              <a:t>até</a:t>
+            </a:r>
+            <a:r>
+              <a:rPr sz="1400" b="0" i="1" dirty="0">
+                <a:solidFill>
+                  <a:srgbClr val="E5CC7A"/>
+                </a:solidFill>
+              </a:rPr>
+              <a:t> 30% do valor da causa</a:t>
+            </a:r>
+          </a:p>
+          <a:p>
+            <a:pPr algn="l">
+              <a:spcBef>
+                <a:spcPts val="1000"/>
+              </a:spcBef>
+            </a:pPr>
+            <a:r>
+              <a:rPr sz="1400" b="0" i="0" dirty="0">
+                <a:solidFill>
+                  <a:srgbClr val="8899AA"/>
+                </a:solidFill>
+              </a:rPr>
+              <a:t>Na </a:t>
+            </a:r>
+            <a:r>
               <a:rPr sz="1400" b="0" i="0" dirty="0" err="1">
                 <a:solidFill>
                   <a:srgbClr val="8899AA"/>
                 </a:solidFill>
-                <a:latin typeface="Calibri"/>
-              </a:rPr>
-              <a:t>Início</a:t>
+              </a:rPr>
+              <a:t>BlindSafe</a:t>
             </a:r>
             <a:r>
               <a:rPr sz="1400" b="0" i="0" dirty="0">
                 <a:solidFill>
                   <a:srgbClr val="8899AA"/>
                 </a:solidFill>
-                <a:latin typeface="Calibri"/>
+              </a:rPr>
+              <a:t>, </a:t>
+            </a:r>
+            <a:r>
+              <a:rPr sz="1400" b="0" i="0" dirty="0" err="1">
+                <a:solidFill>
+                  <a:srgbClr val="8899AA"/>
+                </a:solidFill>
+              </a:rPr>
+              <a:t>dificilmente</a:t>
+            </a:r>
+            <a:r>
+              <a:rPr sz="1400" b="0" i="0" dirty="0">
+                <a:solidFill>
+                  <a:srgbClr val="8899AA"/>
+                </a:solidFill>
               </a:rPr>
               <a:t> </a:t>
             </a:r>
@@ -10466,34 +10857,30 @@
                 <a:solidFill>
                   <a:srgbClr val="8899AA"/>
                 </a:solidFill>
-                <a:latin typeface="Calibri"/>
-              </a:rPr>
-              <a:t>imediato</a:t>
+              </a:rPr>
+              <a:t>nossos</a:t>
             </a:r>
             <a:r>
               <a:rPr sz="1400" b="0" i="0" dirty="0">
                 <a:solidFill>
                   <a:srgbClr val="8899AA"/>
                 </a:solidFill>
-                <a:latin typeface="Calibri"/>
-              </a:rPr>
-              <a:t> dos </a:t>
+              </a:rPr>
+              <a:t> </a:t>
             </a:r>
             <a:r>
               <a:rPr sz="1400" b="0" i="0" dirty="0" err="1">
                 <a:solidFill>
                   <a:srgbClr val="8899AA"/>
                 </a:solidFill>
-                <a:latin typeface="Calibri"/>
-              </a:rPr>
-              <a:t>trabalhos</a:t>
+              </a:rPr>
+              <a:t>honorários</a:t>
             </a:r>
             <a:r>
               <a:rPr sz="1400" b="0" i="0" dirty="0">
                 <a:solidFill>
                   <a:srgbClr val="8899AA"/>
                 </a:solidFill>
-                <a:latin typeface="Calibri"/>
               </a:rPr>
               <a:t> </a:t>
             </a:r>
@@ -10502,16 +10889,30 @@
                 <a:solidFill>
                   <a:srgbClr val="8899AA"/>
                 </a:solidFill>
-                <a:latin typeface="Calibri"/>
-              </a:rPr>
-              <a:t>após</a:t>
+              </a:rPr>
+              <a:t>ultrapassam</a:t>
             </a:r>
             <a:r>
               <a:rPr sz="1400" b="0" i="0" dirty="0">
                 <a:solidFill>
                   <a:srgbClr val="8899AA"/>
                 </a:solidFill>
-                <a:latin typeface="Calibri"/>
+              </a:rPr>
+              <a:t> 10% do valor total da causa. Somos </a:t>
+            </a:r>
+            <a:r>
+              <a:rPr sz="1400" b="0" i="0" dirty="0" err="1">
+                <a:solidFill>
+                  <a:srgbClr val="8899AA"/>
+                </a:solidFill>
+              </a:rPr>
+              <a:t>eficientes</a:t>
+            </a:r>
+            <a:r>
+              <a:rPr sz="1400" b="0" i="0" dirty="0">
+                <a:solidFill>
+                  <a:srgbClr val="8899AA"/>
+                </a:solidFill>
               </a:rPr>
               <a:t> </a:t>
             </a:r>
@@ -10520,88 +10921,30 @@
                 <a:solidFill>
                   <a:srgbClr val="8899AA"/>
                 </a:solidFill>
-                <a:latin typeface="Calibri"/>
-              </a:rPr>
-              <a:t>assinatura</a:t>
-            </a:r>
-            <a:endParaRPr sz="1400" b="0" i="0" dirty="0">
-              <a:solidFill>
-                <a:srgbClr val="8899AA"/>
-              </a:solidFill>
-              <a:latin typeface="Calibri"/>
-            </a:endParaRPr>
-          </a:p>
-        </p:txBody>
-      </p:sp>
-      <p:pic>
-        <p:nvPicPr>
-          <p:cNvPr id="24" name="Picture 23" descr="image5.png"/>
-          <p:cNvPicPr>
-            <a:picLocks noChangeAspect="1"/>
-          </p:cNvPicPr>
-          <p:nvPr/>
-        </p:nvPicPr>
-        <p:blipFill>
-          <a:blip r:embed="rId2"/>
-          <a:stretch>
-            <a:fillRect/>
-          </a:stretch>
-        </p:blipFill>
-        <p:spPr>
-          <a:xfrm>
-            <a:off x="3959352" y="5010912"/>
-            <a:ext cx="292608" cy="292608"/>
-          </a:xfrm>
-          <a:prstGeom prst="rect">
-            <a:avLst/>
-          </a:prstGeom>
-        </p:spPr>
-      </p:pic>
-      <p:sp>
-        <p:nvSpPr>
-          <p:cNvPr id="25" name="TextBox 24"/>
-          <p:cNvSpPr txBox="1"/>
-          <p:nvPr/>
-        </p:nvSpPr>
-        <p:spPr>
-          <a:xfrm>
-            <a:off x="4370832" y="4992624"/>
-            <a:ext cx="2834640" cy="548640"/>
-          </a:xfrm>
-          <a:prstGeom prst="rect">
-            <a:avLst/>
-          </a:prstGeom>
-          <a:noFill/>
-        </p:spPr>
-        <p:txBody>
-          <a:bodyPr wrap="square"/>
-          <a:lstStyle/>
-          <a:p>
-            <a:pPr algn="l"/>
+              </a:rPr>
+              <a:t>porque</a:t>
+            </a:r>
             <a:r>
               <a:rPr sz="1400" b="0" i="0" dirty="0">
                 <a:solidFill>
                   <a:srgbClr val="8899AA"/>
                 </a:solidFill>
-                <a:latin typeface="Calibri"/>
-              </a:rPr>
-              <a:t>5 </a:t>
+              </a:rPr>
+              <a:t> </a:t>
             </a:r>
             <a:r>
               <a:rPr sz="1400" b="0" i="0" dirty="0" err="1">
                 <a:solidFill>
                   <a:srgbClr val="8899AA"/>
                 </a:solidFill>
-                <a:latin typeface="Calibri"/>
-              </a:rPr>
-              <a:t>parcelas</a:t>
+              </a:rPr>
+              <a:t>nosso</a:t>
             </a:r>
             <a:r>
               <a:rPr sz="1400" b="0" i="0" dirty="0">
                 <a:solidFill>
                   <a:srgbClr val="8899AA"/>
                 </a:solidFill>
-                <a:latin typeface="Calibri"/>
               </a:rPr>
               <a:t> </a:t>
             </a:r>
@@ -10610,34 +10953,30 @@
                 <a:solidFill>
                   <a:srgbClr val="8899AA"/>
                 </a:solidFill>
-                <a:latin typeface="Calibri"/>
-              </a:rPr>
-              <a:t>mensais</a:t>
+              </a:rPr>
+              <a:t>objetivo</a:t>
             </a:r>
             <a:r>
               <a:rPr sz="1400" b="0" i="0" dirty="0">
                 <a:solidFill>
                   <a:srgbClr val="8899AA"/>
                 </a:solidFill>
-                <a:latin typeface="Calibri"/>
-              </a:rPr>
-              <a:t> via </a:t>
+              </a:rPr>
+              <a:t> é resolver, e </a:t>
             </a:r>
             <a:r>
               <a:rPr sz="1400" b="0" i="0" dirty="0" err="1">
                 <a:solidFill>
                   <a:srgbClr val="8899AA"/>
                 </a:solidFill>
-                <a:latin typeface="Calibri"/>
-              </a:rPr>
-              <a:t>boleto</a:t>
+              </a:rPr>
+              <a:t>não</a:t>
             </a:r>
             <a:r>
               <a:rPr sz="1400" b="0" i="0" dirty="0">
                 <a:solidFill>
                   <a:srgbClr val="8899AA"/>
                 </a:solidFill>
-                <a:latin typeface="Calibri"/>
               </a:rPr>
               <a:t> </a:t>
             </a:r>
@@ -10646,75 +10985,158 @@
                 <a:solidFill>
                   <a:srgbClr val="8899AA"/>
                 </a:solidFill>
-                <a:latin typeface="Calibri"/>
-              </a:rPr>
-              <a:t>bancário</a:t>
-            </a:r>
-            <a:endParaRPr sz="1400" b="0" i="0" dirty="0">
-              <a:solidFill>
-                <a:srgbClr val="8899AA"/>
-              </a:solidFill>
-              <a:latin typeface="Calibri"/>
-            </a:endParaRPr>
-          </a:p>
-        </p:txBody>
-      </p:sp>
-      <p:sp>
-        <p:nvSpPr>
-          <p:cNvPr id="26" name="Rectangle 25"/>
+              </a:rPr>
+              <a:t>prolongar</a:t>
+            </a:r>
+            <a:r>
+              <a:rPr sz="1400" b="0" i="0" dirty="0">
+                <a:solidFill>
+                  <a:srgbClr val="8899AA"/>
+                </a:solidFill>
+              </a:rPr>
+              <a:t>. Outros </a:t>
+            </a:r>
+            <a:r>
+              <a:rPr sz="1400" b="0" i="0" dirty="0" err="1">
+                <a:solidFill>
+                  <a:srgbClr val="8899AA"/>
+                </a:solidFill>
+              </a:rPr>
+              <a:t>escritórios</a:t>
+            </a:r>
+            <a:r>
+              <a:rPr sz="1400" b="0" i="0" dirty="0">
+                <a:solidFill>
+                  <a:srgbClr val="8899AA"/>
+                </a:solidFill>
+              </a:rPr>
+              <a:t> </a:t>
+            </a:r>
+            <a:r>
+              <a:rPr sz="1400" b="0" i="0" dirty="0" err="1">
+                <a:solidFill>
+                  <a:srgbClr val="8899AA"/>
+                </a:solidFill>
+              </a:rPr>
+              <a:t>chegam</a:t>
+            </a:r>
+            <a:r>
+              <a:rPr sz="1400" b="0" i="0" dirty="0">
+                <a:solidFill>
+                  <a:srgbClr val="8899AA"/>
+                </a:solidFill>
+              </a:rPr>
+              <a:t> a </a:t>
+            </a:r>
+            <a:r>
+              <a:rPr sz="1400" b="0" i="0" dirty="0" err="1">
+                <a:solidFill>
+                  <a:srgbClr val="8899AA"/>
+                </a:solidFill>
+              </a:rPr>
+              <a:t>cobrar</a:t>
+            </a:r>
+            <a:r>
+              <a:rPr sz="1400" b="0" i="0" dirty="0">
+                <a:solidFill>
+                  <a:srgbClr val="8899AA"/>
+                </a:solidFill>
+              </a:rPr>
+              <a:t> </a:t>
+            </a:r>
+            <a:r>
+              <a:rPr sz="1400" b="0" i="0" dirty="0" err="1">
+                <a:solidFill>
+                  <a:srgbClr val="8899AA"/>
+                </a:solidFill>
+              </a:rPr>
+              <a:t>até</a:t>
+            </a:r>
+            <a:r>
+              <a:rPr sz="1400" b="0" i="0" dirty="0">
+                <a:solidFill>
+                  <a:srgbClr val="8899AA"/>
+                </a:solidFill>
+              </a:rPr>
+              <a:t> 30%, </a:t>
+            </a:r>
+            <a:r>
+              <a:rPr sz="1400" b="0" i="0" dirty="0" err="1">
+                <a:solidFill>
+                  <a:srgbClr val="8899AA"/>
+                </a:solidFill>
+              </a:rPr>
+              <a:t>gerando</a:t>
+            </a:r>
+            <a:r>
+              <a:rPr sz="1400" b="0" i="0" dirty="0">
+                <a:solidFill>
+                  <a:srgbClr val="8899AA"/>
+                </a:solidFill>
+              </a:rPr>
+              <a:t> um </a:t>
+            </a:r>
+            <a:r>
+              <a:rPr sz="1400" b="0" i="0" dirty="0" err="1">
+                <a:solidFill>
+                  <a:srgbClr val="8899AA"/>
+                </a:solidFill>
+              </a:rPr>
+              <a:t>custo</a:t>
+            </a:r>
+            <a:r>
+              <a:rPr sz="1400" b="0" i="0" dirty="0">
+                <a:solidFill>
+                  <a:srgbClr val="8899AA"/>
+                </a:solidFill>
+              </a:rPr>
+              <a:t> </a:t>
+            </a:r>
+            <a:r>
+              <a:rPr sz="1400" b="0" i="0" dirty="0" err="1">
+                <a:solidFill>
+                  <a:srgbClr val="8899AA"/>
+                </a:solidFill>
+              </a:rPr>
+              <a:t>enorme</a:t>
+            </a:r>
+            <a:r>
+              <a:rPr sz="1400" b="0" i="0" dirty="0">
+                <a:solidFill>
+                  <a:srgbClr val="8899AA"/>
+                </a:solidFill>
+              </a:rPr>
+              <a:t> para o </a:t>
+            </a:r>
+            <a:r>
+              <a:rPr sz="1400" b="0" i="0" dirty="0" err="1">
+                <a:solidFill>
+                  <a:srgbClr val="8899AA"/>
+                </a:solidFill>
+              </a:rPr>
+              <a:t>cliente</a:t>
+            </a:r>
+            <a:r>
+              <a:rPr sz="1400" b="0" i="0" dirty="0">
+                <a:solidFill>
+                  <a:srgbClr val="8899AA"/>
+                </a:solidFill>
+              </a:rPr>
+              <a:t>.</a:t>
+            </a:r>
+          </a:p>
+        </p:txBody>
+      </p:sp>
+      <p:sp>
+        <p:nvSpPr>
+          <p:cNvPr id="24" name="Rectangle 23"/>
           <p:cNvSpPr/>
           <p:nvPr/>
         </p:nvSpPr>
         <p:spPr>
           <a:xfrm>
-            <a:off x="384048" y="5971032"/>
-            <a:ext cx="6793992" cy="4069080"/>
-          </a:xfrm>
-          <a:prstGeom prst="rect">
-            <a:avLst/>
-          </a:prstGeom>
-          <a:solidFill>
-            <a:srgbClr val="132447"/>
-          </a:solidFill>
-          <a:ln w="6350">
-            <a:solidFill>
-              <a:srgbClr val="1E3060"/>
-            </a:solidFill>
-          </a:ln>
-        </p:spPr>
-        <p:style>
-          <a:lnRef idx="1">
-            <a:schemeClr val="accent1"/>
-          </a:lnRef>
-          <a:fillRef idx="3">
-            <a:schemeClr val="accent1"/>
-          </a:fillRef>
-          <a:effectRef idx="2">
-            <a:schemeClr val="accent1"/>
-          </a:effectRef>
-          <a:fontRef idx="minor">
-            <a:schemeClr val="lt1"/>
-          </a:fontRef>
-        </p:style>
-        <p:txBody>
-          <a:bodyPr rtlCol="0" anchor="ctr"/>
-          <a:lstStyle/>
-          <a:p>
-            <a:pPr algn="ctr"/>
-            <a:endParaRPr/>
-          </a:p>
-        </p:txBody>
-      </p:sp>
-      <p:sp>
-        <p:nvSpPr>
-          <p:cNvPr id="27" name="Rectangle 26"/>
-          <p:cNvSpPr/>
-          <p:nvPr/>
-        </p:nvSpPr>
-        <p:spPr>
-          <a:xfrm>
-            <a:off x="384048" y="5971032"/>
-            <a:ext cx="50292" cy="4069080"/>
+            <a:off x="384048" y="5000000"/>
+            <a:ext cx="300000" cy="300000"/>
           </a:xfrm>
           <a:prstGeom prst="rect">
             <a:avLst/>
@@ -10749,40 +11171,16 @@
           </a:p>
         </p:txBody>
       </p:sp>
-      <p:pic>
-        <p:nvPicPr>
-          <p:cNvPr id="28" name="Picture 27" descr="image5.png"/>
-          <p:cNvPicPr>
-            <a:picLocks noChangeAspect="1"/>
-          </p:cNvPicPr>
-          <p:nvPr/>
-        </p:nvPicPr>
-        <p:blipFill>
-          <a:blip r:embed="rId2"/>
-          <a:stretch>
-            <a:fillRect/>
-          </a:stretch>
-        </p:blipFill>
-        <p:spPr>
-          <a:xfrm>
-            <a:off x="6053328" y="6172200"/>
-            <a:ext cx="411480" cy="411480"/>
-          </a:xfrm>
-          <a:prstGeom prst="rect">
-            <a:avLst/>
-          </a:prstGeom>
-        </p:spPr>
-      </p:pic>
-      <p:sp>
-        <p:nvSpPr>
-          <p:cNvPr id="29" name="TextBox 28"/>
+      <p:sp>
+        <p:nvSpPr>
+          <p:cNvPr id="25" name="TextBox 24"/>
           <p:cNvSpPr txBox="1"/>
           <p:nvPr/>
         </p:nvSpPr>
         <p:spPr>
           <a:xfrm>
-            <a:off x="621792" y="6172200"/>
-            <a:ext cx="2743200" cy="256032"/>
+            <a:off x="384048" y="5030000"/>
+            <a:ext cx="300000" cy="270000"/>
           </a:xfrm>
           <a:prstGeom prst="rect">
             <a:avLst/>
@@ -10790,98 +11188,561 @@
           <a:noFill/>
         </p:spPr>
         <p:txBody>
-          <a:bodyPr wrap="square"/>
+          <a:bodyPr wrap="square" lIns="0" tIns="0" rIns="0" bIns="0">
+            <a:spAutoFit/>
+          </a:bodyPr>
+          <a:lstStyle/>
+          <a:p>
+            <a:pPr algn="ctr"/>
+            <a:r>
+              <a:rPr sz="1800" b="1" i="0">
+                <a:solidFill>
+                  <a:srgbClr val="182D56"/>
+                </a:solidFill>
+              </a:rPr>
+              <a:t>02</a:t>
+            </a:r>
+          </a:p>
+        </p:txBody>
+      </p:sp>
+      <p:sp>
+        <p:nvSpPr>
+          <p:cNvPr id="26" name="TextBox 25"/>
+          <p:cNvSpPr txBox="1"/>
+          <p:nvPr/>
+        </p:nvSpPr>
+        <p:spPr>
+          <a:xfrm>
+            <a:off x="774048" y="5000000"/>
+            <a:ext cx="6403992" cy="1343958"/>
+          </a:xfrm>
+          <a:prstGeom prst="rect">
+            <a:avLst/>
+          </a:prstGeom>
+          <a:noFill/>
+        </p:spPr>
+        <p:txBody>
+          <a:bodyPr wrap="square" lIns="0" tIns="0" rIns="0" bIns="0">
+            <a:spAutoFit/>
+          </a:bodyPr>
           <a:lstStyle/>
           <a:p>
             <a:pPr algn="l"/>
             <a:r>
-              <a:rPr sz="1400" b="1" i="0" spc="200" dirty="0">
+              <a:rPr b="1" i="0" dirty="0">
+                <a:solidFill>
+                  <a:srgbClr val="FFFFFF"/>
+                </a:solidFill>
+              </a:rPr>
+              <a:t>Sem taxa de </a:t>
+            </a:r>
+            <a:r>
+              <a:rPr b="1" i="0" dirty="0" err="1">
+                <a:solidFill>
+                  <a:srgbClr val="FFFFFF"/>
+                </a:solidFill>
+              </a:rPr>
+              <a:t>manutenção</a:t>
+            </a:r>
+            <a:endParaRPr b="1" i="0" dirty="0">
+              <a:solidFill>
+                <a:srgbClr val="FFFFFF"/>
+              </a:solidFill>
+            </a:endParaRPr>
+          </a:p>
+          <a:p>
+            <a:pPr algn="l">
+              <a:spcBef>
+                <a:spcPts val="600"/>
+              </a:spcBef>
+            </a:pPr>
+            <a:r>
+              <a:rPr sz="1400" b="0" i="1" dirty="0" err="1">
                 <a:solidFill>
                   <a:srgbClr val="E5CC7A"/>
                 </a:solidFill>
-                <a:latin typeface="Calibri"/>
-              </a:rPr>
-              <a:t>OPÇÃO 02</a:t>
-            </a:r>
-          </a:p>
-        </p:txBody>
-      </p:sp>
-      <p:sp>
-        <p:nvSpPr>
-          <p:cNvPr id="30" name="TextBox 29"/>
-          <p:cNvSpPr txBox="1"/>
-          <p:nvPr/>
-        </p:nvSpPr>
-        <p:spPr>
-          <a:xfrm>
-            <a:off x="621792" y="6501384"/>
-            <a:ext cx="6400800" cy="402336"/>
-          </a:xfrm>
-          <a:prstGeom prst="rect">
-            <a:avLst/>
-          </a:prstGeom>
-          <a:noFill/>
-        </p:spPr>
-        <p:txBody>
-          <a:bodyPr wrap="square"/>
-          <a:lstStyle/>
-          <a:p>
-            <a:pPr algn="l"/>
-            <a:r>
-              <a:rPr sz="2000" b="1" i="0" dirty="0" err="1">
-                <a:solidFill>
-                  <a:srgbClr val="FFFFFF"/>
-                </a:solidFill>
-                <a:latin typeface="Georgia"/>
-              </a:rPr>
-              <a:t>Pagamento</a:t>
-            </a:r>
-            <a:r>
-              <a:rPr sz="2000" b="1" i="0" dirty="0">
-                <a:solidFill>
-                  <a:srgbClr val="FFFFFF"/>
-                </a:solidFill>
-                <a:latin typeface="Georgia"/>
-              </a:rPr>
-              <a:t> via </a:t>
-            </a:r>
-            <a:r>
-              <a:rPr sz="2000" b="1" i="0" dirty="0" err="1">
-                <a:solidFill>
-                  <a:srgbClr val="FFFFFF"/>
-                </a:solidFill>
-                <a:latin typeface="Georgia"/>
-              </a:rPr>
-              <a:t>Cartão</a:t>
-            </a:r>
-            <a:r>
-              <a:rPr sz="2000" b="1" i="0" dirty="0">
-                <a:solidFill>
-                  <a:srgbClr val="FFFFFF"/>
-                </a:solidFill>
-                <a:latin typeface="Georgia"/>
-              </a:rPr>
-              <a:t> de Crédito</a:t>
-            </a:r>
-          </a:p>
-        </p:txBody>
-      </p:sp>
-      <p:sp>
-        <p:nvSpPr>
-          <p:cNvPr id="31" name="Rectangle 30"/>
+              </a:rPr>
+              <a:t>Nenhuma</a:t>
+            </a:r>
+            <a:r>
+              <a:rPr sz="1400" b="0" i="1" dirty="0">
+                <a:solidFill>
+                  <a:srgbClr val="E5CC7A"/>
+                </a:solidFill>
+              </a:rPr>
+              <a:t> </a:t>
+            </a:r>
+            <a:r>
+              <a:rPr sz="1400" b="0" i="1" dirty="0" err="1">
+                <a:solidFill>
+                  <a:srgbClr val="E5CC7A"/>
+                </a:solidFill>
+              </a:rPr>
+              <a:t>cobrança</a:t>
+            </a:r>
+            <a:r>
+              <a:rPr sz="1400" b="0" i="1" dirty="0">
+                <a:solidFill>
+                  <a:srgbClr val="E5CC7A"/>
+                </a:solidFill>
+              </a:rPr>
+              <a:t> </a:t>
+            </a:r>
+            <a:r>
+              <a:rPr lang="pt-BR" sz="1400" i="1" dirty="0">
+                <a:solidFill>
+                  <a:srgbClr val="E5CC7A"/>
+                </a:solidFill>
+              </a:rPr>
+              <a:t>além</a:t>
+            </a:r>
+            <a:r>
+              <a:rPr sz="1400" b="0" i="1" dirty="0">
+                <a:solidFill>
+                  <a:srgbClr val="E5CC7A"/>
+                </a:solidFill>
+              </a:rPr>
+              <a:t> </a:t>
+            </a:r>
+            <a:r>
+              <a:rPr lang="pt-BR" sz="1400" b="0" i="1" dirty="0">
+                <a:solidFill>
+                  <a:srgbClr val="E5CC7A"/>
+                </a:solidFill>
+              </a:rPr>
+              <a:t>dos honorários </a:t>
+            </a:r>
+            <a:r>
+              <a:rPr sz="1400" b="0" i="1" dirty="0">
+                <a:solidFill>
+                  <a:srgbClr val="E5CC7A"/>
+                </a:solidFill>
+              </a:rPr>
+              <a:t>para </a:t>
+            </a:r>
+            <a:r>
+              <a:rPr sz="1400" b="0" i="1" dirty="0" err="1">
+                <a:solidFill>
+                  <a:srgbClr val="E5CC7A"/>
+                </a:solidFill>
+              </a:rPr>
+              <a:t>continuar</a:t>
+            </a:r>
+            <a:r>
+              <a:rPr sz="1400" b="0" i="1" dirty="0">
+                <a:solidFill>
+                  <a:srgbClr val="E5CC7A"/>
+                </a:solidFill>
+              </a:rPr>
+              <a:t> </a:t>
+            </a:r>
+            <a:r>
+              <a:rPr sz="1400" b="0" i="1" dirty="0" err="1">
+                <a:solidFill>
+                  <a:srgbClr val="E5CC7A"/>
+                </a:solidFill>
+              </a:rPr>
+              <a:t>trabalhando</a:t>
+            </a:r>
+            <a:r>
+              <a:rPr sz="1400" b="0" i="1" dirty="0">
+                <a:solidFill>
+                  <a:srgbClr val="E5CC7A"/>
+                </a:solidFill>
+              </a:rPr>
+              <a:t> no </a:t>
+            </a:r>
+            <a:r>
+              <a:rPr sz="1400" b="0" i="1" dirty="0" err="1">
+                <a:solidFill>
+                  <a:srgbClr val="E5CC7A"/>
+                </a:solidFill>
+              </a:rPr>
+              <a:t>seu</a:t>
+            </a:r>
+            <a:r>
+              <a:rPr sz="1400" b="0" i="1" dirty="0">
+                <a:solidFill>
+                  <a:srgbClr val="E5CC7A"/>
+                </a:solidFill>
+              </a:rPr>
+              <a:t> </a:t>
+            </a:r>
+            <a:r>
+              <a:rPr sz="1400" b="0" i="1" dirty="0" err="1">
+                <a:solidFill>
+                  <a:srgbClr val="E5CC7A"/>
+                </a:solidFill>
+              </a:rPr>
+              <a:t>caso</a:t>
+            </a:r>
+            <a:endParaRPr sz="1400" b="0" i="1" dirty="0">
+              <a:solidFill>
+                <a:srgbClr val="E5CC7A"/>
+              </a:solidFill>
+            </a:endParaRPr>
+          </a:p>
+          <a:p>
+            <a:pPr algn="l">
+              <a:spcBef>
+                <a:spcPts val="1000"/>
+              </a:spcBef>
+            </a:pPr>
+            <a:r>
+              <a:rPr sz="1400" b="0" i="0" dirty="0" err="1">
+                <a:solidFill>
+                  <a:srgbClr val="8899AA"/>
+                </a:solidFill>
+              </a:rPr>
+              <a:t>Diferentemente</a:t>
+            </a:r>
+            <a:r>
+              <a:rPr sz="1400" b="0" i="0" dirty="0">
+                <a:solidFill>
+                  <a:srgbClr val="8899AA"/>
+                </a:solidFill>
+              </a:rPr>
+              <a:t> de </a:t>
+            </a:r>
+            <a:r>
+              <a:rPr sz="1400" b="0" i="0" dirty="0" err="1">
+                <a:solidFill>
+                  <a:srgbClr val="8899AA"/>
+                </a:solidFill>
+              </a:rPr>
+              <a:t>muitos</a:t>
+            </a:r>
+            <a:r>
+              <a:rPr sz="1400" b="0" i="0" dirty="0">
+                <a:solidFill>
+                  <a:srgbClr val="8899AA"/>
+                </a:solidFill>
+              </a:rPr>
+              <a:t> </a:t>
+            </a:r>
+            <a:r>
+              <a:rPr sz="1400" b="0" i="0" dirty="0" err="1">
+                <a:solidFill>
+                  <a:srgbClr val="8899AA"/>
+                </a:solidFill>
+              </a:rPr>
+              <a:t>escritórios</a:t>
+            </a:r>
+            <a:r>
+              <a:rPr sz="1400" b="0" i="0" dirty="0">
+                <a:solidFill>
+                  <a:srgbClr val="8899AA"/>
+                </a:solidFill>
+              </a:rPr>
+              <a:t>, a </a:t>
+            </a:r>
+            <a:r>
+              <a:rPr sz="1400" b="0" i="0" dirty="0" err="1">
+                <a:solidFill>
+                  <a:srgbClr val="8899AA"/>
+                </a:solidFill>
+              </a:rPr>
+              <a:t>BlindSafe</a:t>
+            </a:r>
+            <a:r>
+              <a:rPr sz="1400" b="0" i="0" dirty="0">
+                <a:solidFill>
+                  <a:srgbClr val="8899AA"/>
+                </a:solidFill>
+              </a:rPr>
+              <a:t> </a:t>
+            </a:r>
+            <a:r>
+              <a:rPr sz="1400" b="0" i="0" dirty="0" err="1">
+                <a:solidFill>
+                  <a:srgbClr val="8899AA"/>
+                </a:solidFill>
+              </a:rPr>
+              <a:t>não</a:t>
+            </a:r>
+            <a:r>
+              <a:rPr sz="1400" b="0" i="0" dirty="0">
+                <a:solidFill>
+                  <a:srgbClr val="8899AA"/>
+                </a:solidFill>
+              </a:rPr>
+              <a:t> cobra </a:t>
+            </a:r>
+            <a:r>
+              <a:rPr sz="1400" b="0" i="0" dirty="0" err="1">
+                <a:solidFill>
+                  <a:srgbClr val="8899AA"/>
+                </a:solidFill>
+              </a:rPr>
+              <a:t>taxas</a:t>
+            </a:r>
+            <a:r>
+              <a:rPr sz="1400" b="0" i="0" dirty="0">
+                <a:solidFill>
+                  <a:srgbClr val="8899AA"/>
+                </a:solidFill>
+              </a:rPr>
+              <a:t> de </a:t>
+            </a:r>
+            <a:r>
+              <a:rPr sz="1400" b="0" i="0" dirty="0" err="1">
+                <a:solidFill>
+                  <a:srgbClr val="8899AA"/>
+                </a:solidFill>
+              </a:rPr>
+              <a:t>manutenção</a:t>
+            </a:r>
+            <a:r>
+              <a:rPr sz="1400" b="0" i="0" dirty="0">
+                <a:solidFill>
+                  <a:srgbClr val="8899AA"/>
+                </a:solidFill>
+              </a:rPr>
+              <a:t>. Uma </a:t>
+            </a:r>
+            <a:r>
+              <a:rPr sz="1400" b="0" i="0" dirty="0" err="1">
+                <a:solidFill>
+                  <a:srgbClr val="8899AA"/>
+                </a:solidFill>
+              </a:rPr>
+              <a:t>vez</a:t>
+            </a:r>
+            <a:r>
+              <a:rPr sz="1400" b="0" i="0" dirty="0">
+                <a:solidFill>
+                  <a:srgbClr val="8899AA"/>
+                </a:solidFill>
+              </a:rPr>
+              <a:t> </a:t>
+            </a:r>
+            <a:r>
+              <a:rPr sz="1400" b="0" i="0" dirty="0" err="1">
+                <a:solidFill>
+                  <a:srgbClr val="8899AA"/>
+                </a:solidFill>
+              </a:rPr>
+              <a:t>contratados</a:t>
+            </a:r>
+            <a:r>
+              <a:rPr sz="1400" b="0" i="0" dirty="0">
+                <a:solidFill>
+                  <a:srgbClr val="8899AA"/>
+                </a:solidFill>
+              </a:rPr>
+              <a:t>, </a:t>
+            </a:r>
+            <a:r>
+              <a:rPr sz="1400" b="0" i="0" dirty="0" err="1">
+                <a:solidFill>
+                  <a:srgbClr val="8899AA"/>
+                </a:solidFill>
+              </a:rPr>
+              <a:t>trabalhamos</a:t>
+            </a:r>
+            <a:r>
+              <a:rPr sz="1400" b="0" i="0" dirty="0">
+                <a:solidFill>
+                  <a:srgbClr val="8899AA"/>
+                </a:solidFill>
+              </a:rPr>
+              <a:t> </a:t>
+            </a:r>
+            <a:r>
+              <a:rPr sz="1400" b="0" i="0" dirty="0" err="1">
+                <a:solidFill>
+                  <a:srgbClr val="8899AA"/>
+                </a:solidFill>
+              </a:rPr>
+              <a:t>até</a:t>
+            </a:r>
+            <a:r>
+              <a:rPr sz="1400" b="0" i="0" dirty="0">
+                <a:solidFill>
+                  <a:srgbClr val="8899AA"/>
+                </a:solidFill>
+              </a:rPr>
+              <a:t> a </a:t>
+            </a:r>
+            <a:r>
+              <a:rPr sz="1400" b="0" i="0" dirty="0" err="1">
+                <a:solidFill>
+                  <a:srgbClr val="8899AA"/>
+                </a:solidFill>
+              </a:rPr>
+              <a:t>conclusão</a:t>
+            </a:r>
+            <a:r>
+              <a:rPr sz="1400" b="0" i="0" dirty="0">
+                <a:solidFill>
+                  <a:srgbClr val="8899AA"/>
+                </a:solidFill>
+              </a:rPr>
+              <a:t> </a:t>
+            </a:r>
+            <a:r>
+              <a:rPr sz="1400" b="0" i="0" dirty="0" err="1">
+                <a:solidFill>
+                  <a:srgbClr val="8899AA"/>
+                </a:solidFill>
+              </a:rPr>
+              <a:t>sem</a:t>
+            </a:r>
+            <a:r>
+              <a:rPr sz="1400" b="0" i="0" dirty="0">
+                <a:solidFill>
+                  <a:srgbClr val="8899AA"/>
+                </a:solidFill>
+              </a:rPr>
+              <a:t> </a:t>
+            </a:r>
+            <a:r>
+              <a:rPr sz="1400" b="0" i="0" dirty="0" err="1">
+                <a:solidFill>
+                  <a:srgbClr val="8899AA"/>
+                </a:solidFill>
+              </a:rPr>
+              <a:t>cobranças</a:t>
+            </a:r>
+            <a:r>
+              <a:rPr sz="1400" b="0" i="0" dirty="0">
+                <a:solidFill>
+                  <a:srgbClr val="8899AA"/>
+                </a:solidFill>
+              </a:rPr>
+              <a:t> extras</a:t>
+            </a:r>
+            <a:r>
+              <a:rPr lang="pt-BR" sz="1400" b="0" i="0" dirty="0">
+                <a:solidFill>
+                  <a:srgbClr val="8899AA"/>
+                </a:solidFill>
+              </a:rPr>
+              <a:t> de honorários</a:t>
+            </a:r>
+            <a:r>
+              <a:rPr sz="1400" b="0" i="0" dirty="0">
+                <a:solidFill>
+                  <a:srgbClr val="8899AA"/>
+                </a:solidFill>
+              </a:rPr>
+              <a:t>. </a:t>
+            </a:r>
+            <a:r>
+              <a:rPr sz="1400" b="0" i="0" dirty="0" err="1">
+                <a:solidFill>
+                  <a:srgbClr val="8899AA"/>
+                </a:solidFill>
+              </a:rPr>
+              <a:t>Nosso</a:t>
+            </a:r>
+            <a:r>
+              <a:rPr sz="1400" b="0" i="0" dirty="0">
+                <a:solidFill>
+                  <a:srgbClr val="8899AA"/>
+                </a:solidFill>
+              </a:rPr>
+              <a:t> interesse é resolver o </a:t>
+            </a:r>
+            <a:r>
+              <a:rPr sz="1400" b="0" i="0" dirty="0" err="1">
+                <a:solidFill>
+                  <a:srgbClr val="8899AA"/>
+                </a:solidFill>
+              </a:rPr>
+              <a:t>seu</a:t>
+            </a:r>
+            <a:r>
+              <a:rPr sz="1400" b="0" i="0" dirty="0">
+                <a:solidFill>
+                  <a:srgbClr val="8899AA"/>
+                </a:solidFill>
+              </a:rPr>
+              <a:t> </a:t>
+            </a:r>
+            <a:r>
+              <a:rPr sz="1400" b="0" i="0" dirty="0" err="1">
+                <a:solidFill>
+                  <a:srgbClr val="8899AA"/>
+                </a:solidFill>
+              </a:rPr>
+              <a:t>problema</a:t>
+            </a:r>
+            <a:r>
+              <a:rPr sz="1400" b="0" i="0" dirty="0">
+                <a:solidFill>
+                  <a:srgbClr val="8899AA"/>
+                </a:solidFill>
+              </a:rPr>
+              <a:t> o </a:t>
+            </a:r>
+            <a:r>
+              <a:rPr sz="1400" b="0" i="0" dirty="0" err="1">
+                <a:solidFill>
+                  <a:srgbClr val="8899AA"/>
+                </a:solidFill>
+              </a:rPr>
+              <a:t>mais</a:t>
+            </a:r>
+            <a:r>
+              <a:rPr sz="1400" b="0" i="0" dirty="0">
+                <a:solidFill>
+                  <a:srgbClr val="8899AA"/>
+                </a:solidFill>
+              </a:rPr>
+              <a:t> </a:t>
+            </a:r>
+            <a:r>
+              <a:rPr sz="1400" b="0" i="0" dirty="0" err="1">
+                <a:solidFill>
+                  <a:srgbClr val="8899AA"/>
+                </a:solidFill>
+              </a:rPr>
+              <a:t>rápido</a:t>
+            </a:r>
+            <a:r>
+              <a:rPr sz="1400" b="0" i="0" dirty="0">
+                <a:solidFill>
+                  <a:srgbClr val="8899AA"/>
+                </a:solidFill>
+              </a:rPr>
+              <a:t> </a:t>
+            </a:r>
+            <a:r>
+              <a:rPr sz="1400" b="0" i="0" dirty="0" err="1">
+                <a:solidFill>
+                  <a:srgbClr val="8899AA"/>
+                </a:solidFill>
+              </a:rPr>
+              <a:t>possível</a:t>
+            </a:r>
+            <a:r>
+              <a:rPr sz="1400" b="0" i="0" dirty="0">
+                <a:solidFill>
+                  <a:srgbClr val="8899AA"/>
+                </a:solidFill>
+              </a:rPr>
+              <a:t>.</a:t>
+            </a:r>
+          </a:p>
+        </p:txBody>
+      </p:sp>
+      <p:sp>
+        <p:nvSpPr>
+          <p:cNvPr id="27" name="Rectangle 26"/>
           <p:cNvSpPr/>
           <p:nvPr/>
         </p:nvSpPr>
         <p:spPr>
           <a:xfrm>
-            <a:off x="621792" y="7050024"/>
-            <a:ext cx="6400800" cy="27432"/>
+            <a:off x="384048" y="6870000"/>
+            <a:ext cx="300000" cy="300000"/>
           </a:xfrm>
           <a:prstGeom prst="rect">
             <a:avLst/>
           </a:prstGeom>
           <a:solidFill>
-            <a:srgbClr val="2A4070"/>
+            <a:srgbClr val="C9A84C"/>
           </a:solidFill>
           <a:ln>
             <a:noFill/>
@@ -10912,14 +11773,14 @@
       </p:sp>
       <p:sp>
         <p:nvSpPr>
-          <p:cNvPr id="32" name="TextBox 31"/>
+          <p:cNvPr id="28" name="TextBox 27"/>
           <p:cNvSpPr txBox="1"/>
           <p:nvPr/>
         </p:nvSpPr>
         <p:spPr>
           <a:xfrm>
-            <a:off x="621792" y="7251192"/>
-            <a:ext cx="2194560" cy="228600"/>
+            <a:off x="384048" y="6900000"/>
+            <a:ext cx="300000" cy="270000"/>
           </a:xfrm>
           <a:prstGeom prst="rect">
             <a:avLst/>
@@ -10927,212 +11788,569 @@
           <a:noFill/>
         </p:spPr>
         <p:txBody>
-          <a:bodyPr wrap="square"/>
+          <a:bodyPr wrap="square" lIns="0" tIns="0" rIns="0" bIns="0">
+            <a:spAutoFit/>
+          </a:bodyPr>
+          <a:lstStyle/>
+          <a:p>
+            <a:pPr algn="ctr"/>
+            <a:r>
+              <a:rPr sz="1800" b="1" i="0">
+                <a:solidFill>
+                  <a:srgbClr val="182D56"/>
+                </a:solidFill>
+              </a:rPr>
+              <a:t>03</a:t>
+            </a:r>
+          </a:p>
+        </p:txBody>
+      </p:sp>
+      <p:sp>
+        <p:nvSpPr>
+          <p:cNvPr id="29" name="TextBox 28"/>
+          <p:cNvSpPr txBox="1"/>
+          <p:nvPr/>
+        </p:nvSpPr>
+        <p:spPr>
+          <a:xfrm>
+            <a:off x="774048" y="6870000"/>
+            <a:ext cx="6403992" cy="1343958"/>
+          </a:xfrm>
+          <a:prstGeom prst="rect">
+            <a:avLst/>
+          </a:prstGeom>
+          <a:noFill/>
+        </p:spPr>
+        <p:txBody>
+          <a:bodyPr wrap="square" lIns="0" tIns="0" rIns="0" bIns="0">
+            <a:spAutoFit/>
+          </a:bodyPr>
           <a:lstStyle/>
           <a:p>
             <a:pPr algn="l"/>
             <a:r>
-              <a:rPr sz="1200" b="1" i="0" spc="100" dirty="0">
+              <a:rPr b="1" i="0" dirty="0">
+                <a:solidFill>
+                  <a:srgbClr val="FFFFFF"/>
+                </a:solidFill>
+              </a:rPr>
+              <a:t>Sem </a:t>
+            </a:r>
+            <a:r>
+              <a:rPr b="1" i="0" dirty="0" err="1">
+                <a:solidFill>
+                  <a:srgbClr val="FFFFFF"/>
+                </a:solidFill>
+              </a:rPr>
+              <a:t>cobrança</a:t>
+            </a:r>
+            <a:r>
+              <a:rPr b="1" i="0" dirty="0">
+                <a:solidFill>
+                  <a:srgbClr val="FFFFFF"/>
+                </a:solidFill>
+              </a:rPr>
+              <a:t> </a:t>
+            </a:r>
+            <a:r>
+              <a:rPr b="1" i="0" dirty="0" err="1">
+                <a:solidFill>
+                  <a:srgbClr val="FFFFFF"/>
+                </a:solidFill>
+              </a:rPr>
+              <a:t>sobre</a:t>
+            </a:r>
+            <a:r>
+              <a:rPr b="1" i="0" dirty="0">
+                <a:solidFill>
+                  <a:srgbClr val="FFFFFF"/>
+                </a:solidFill>
+              </a:rPr>
+              <a:t> a </a:t>
+            </a:r>
+            <a:r>
+              <a:rPr b="1" i="0" dirty="0" err="1">
+                <a:solidFill>
+                  <a:srgbClr val="FFFFFF"/>
+                </a:solidFill>
+              </a:rPr>
+              <a:t>redução</a:t>
+            </a:r>
+            <a:r>
+              <a:rPr b="1" i="0" dirty="0">
+                <a:solidFill>
+                  <a:srgbClr val="FFFFFF"/>
+                </a:solidFill>
+              </a:rPr>
+              <a:t> da </a:t>
+            </a:r>
+            <a:r>
+              <a:rPr b="1" i="0" dirty="0" err="1">
+                <a:solidFill>
+                  <a:srgbClr val="FFFFFF"/>
+                </a:solidFill>
+              </a:rPr>
+              <a:t>dívida</a:t>
+            </a:r>
+            <a:endParaRPr b="1" i="0" dirty="0">
+              <a:solidFill>
+                <a:srgbClr val="FFFFFF"/>
+              </a:solidFill>
+            </a:endParaRPr>
+          </a:p>
+          <a:p>
+            <a:pPr algn="l">
+              <a:spcBef>
+                <a:spcPts val="600"/>
+              </a:spcBef>
+            </a:pPr>
+            <a:r>
+              <a:rPr sz="1400" b="0" i="1" dirty="0">
                 <a:solidFill>
                   <a:srgbClr val="E5CC7A"/>
                 </a:solidFill>
-                <a:latin typeface="Calibri"/>
-              </a:rPr>
-              <a:t>À VISTA</a:t>
-            </a:r>
-          </a:p>
-        </p:txBody>
-      </p:sp>
-      <p:sp>
-        <p:nvSpPr>
-          <p:cNvPr id="33" name="TextBox 32"/>
-          <p:cNvSpPr txBox="1"/>
-          <p:nvPr/>
-        </p:nvSpPr>
-        <p:spPr>
-          <a:xfrm>
-            <a:off x="621792" y="7507224"/>
-            <a:ext cx="2194560" cy="475488"/>
-          </a:xfrm>
-          <a:prstGeom prst="rect">
-            <a:avLst/>
-          </a:prstGeom>
-          <a:noFill/>
-        </p:spPr>
-        <p:txBody>
-          <a:bodyPr wrap="square"/>
-          <a:lstStyle/>
-          <a:p>
-            <a:pPr algn="l"/>
-            <a:r>
-              <a:rPr sz="2000" b="1" i="0" dirty="0">
-                <a:solidFill>
-                  <a:srgbClr val="FFFFFF"/>
-                </a:solidFill>
-                <a:latin typeface="Calibri"/>
-              </a:rPr>
-              <a:t>{{OP2_AVISTA}}</a:t>
-            </a:r>
-          </a:p>
-        </p:txBody>
-      </p:sp>
-      <p:sp>
-        <p:nvSpPr>
-          <p:cNvPr id="34" name="TextBox 33"/>
-          <p:cNvSpPr txBox="1"/>
-          <p:nvPr/>
-        </p:nvSpPr>
-        <p:spPr>
-          <a:xfrm>
-            <a:off x="2743200" y="7251192"/>
-            <a:ext cx="2194560" cy="228600"/>
-          </a:xfrm>
-          <a:prstGeom prst="rect">
-            <a:avLst/>
-          </a:prstGeom>
-          <a:noFill/>
-        </p:spPr>
-        <p:txBody>
-          <a:bodyPr wrap="square"/>
-          <a:lstStyle/>
-          <a:p>
-            <a:pPr algn="l"/>
-            <a:r>
-              <a:rPr sz="1200" b="1" i="0" spc="100" dirty="0">
+              </a:rPr>
+              <a:t>O </a:t>
+            </a:r>
+            <a:r>
+              <a:rPr sz="1400" b="0" i="1" dirty="0" err="1">
                 <a:solidFill>
                   <a:srgbClr val="E5CC7A"/>
                 </a:solidFill>
-                <a:latin typeface="Calibri"/>
-              </a:rPr>
-              <a:t>PARCELADO</a:t>
-            </a:r>
-          </a:p>
-        </p:txBody>
-      </p:sp>
-      <p:sp>
-        <p:nvSpPr>
-          <p:cNvPr id="35" name="TextBox 34"/>
-          <p:cNvSpPr txBox="1"/>
-          <p:nvPr/>
-        </p:nvSpPr>
-        <p:spPr>
-          <a:xfrm>
-            <a:off x="2743200" y="7507224"/>
-            <a:ext cx="2194560" cy="475488"/>
-          </a:xfrm>
-          <a:prstGeom prst="rect">
-            <a:avLst/>
-          </a:prstGeom>
-          <a:noFill/>
-        </p:spPr>
-        <p:txBody>
-          <a:bodyPr wrap="square"/>
-          <a:lstStyle/>
-          <a:p>
-            <a:pPr algn="l"/>
-            <a:r>
-              <a:rPr sz="2000" b="1" i="0" dirty="0" err="1">
-                <a:solidFill>
-                  <a:srgbClr val="FFFFFF"/>
-                </a:solidFill>
-                <a:latin typeface="Calibri"/>
-              </a:rPr>
-              <a:t>{{OP2_ATE_PARCELAS}}</a:t>
-            </a:r>
-            <a:r>
-              <a:rPr sz="2000" b="1" i="0" dirty="0">
-                <a:solidFill>
-                  <a:srgbClr val="FFFFFF"/>
-                </a:solidFill>
-                <a:latin typeface="Calibri"/>
-              </a:rPr>
-              <a:t/>
-            </a:r>
-          </a:p>
-        </p:txBody>
-      </p:sp>
-      <p:sp>
-        <p:nvSpPr>
-          <p:cNvPr id="36" name="TextBox 35"/>
-          <p:cNvSpPr txBox="1"/>
-          <p:nvPr/>
-        </p:nvSpPr>
-        <p:spPr>
-          <a:xfrm>
-            <a:off x="4892040" y="7251192"/>
-            <a:ext cx="2194560" cy="228600"/>
-          </a:xfrm>
-          <a:prstGeom prst="rect">
-            <a:avLst/>
-          </a:prstGeom>
-          <a:noFill/>
-        </p:spPr>
-        <p:txBody>
-          <a:bodyPr wrap="square"/>
-          <a:lstStyle/>
-          <a:p>
-            <a:pPr algn="l"/>
-            <a:r>
-              <a:rPr sz="1200" b="1" i="0" spc="100" dirty="0">
+              </a:rPr>
+              <a:t>que</a:t>
+            </a:r>
+            <a:r>
+              <a:rPr sz="1400" b="0" i="1" dirty="0">
                 <a:solidFill>
                   <a:srgbClr val="E5CC7A"/>
                 </a:solidFill>
-                <a:latin typeface="Calibri"/>
-              </a:rPr>
-              <a:t>SEM JUROS</a:t>
-            </a:r>
-          </a:p>
-        </p:txBody>
-      </p:sp>
-      <p:sp>
-        <p:nvSpPr>
-          <p:cNvPr id="37" name="TextBox 36"/>
-          <p:cNvSpPr txBox="1"/>
-          <p:nvPr/>
-        </p:nvSpPr>
-        <p:spPr>
-          <a:xfrm>
-            <a:off x="4892040" y="7507224"/>
-            <a:ext cx="2194560" cy="475488"/>
-          </a:xfrm>
-          <a:prstGeom prst="rect">
-            <a:avLst/>
-          </a:prstGeom>
-          <a:noFill/>
-        </p:spPr>
-        <p:txBody>
-          <a:bodyPr wrap="square"/>
-          <a:lstStyle/>
-          <a:p>
-            <a:pPr algn="l"/>
-            <a:r>
-              <a:rPr sz="2000" b="1" i="0" dirty="0">
-                <a:solidFill>
-                  <a:srgbClr val="FFFFFF"/>
-                </a:solidFill>
-                <a:latin typeface="Calibri"/>
-              </a:rPr>
-              <a:t>{{OP2_VALOR_PARCELA}}</a:t>
-            </a:r>
-          </a:p>
-        </p:txBody>
-      </p:sp>
-      <p:sp>
-        <p:nvSpPr>
-          <p:cNvPr id="38" name="Rectangle 37"/>
+              </a:rPr>
+              <a:t> </a:t>
+            </a:r>
+            <a:r>
+              <a:rPr sz="1400" b="0" i="1" dirty="0" err="1">
+                <a:solidFill>
+                  <a:srgbClr val="E5CC7A"/>
+                </a:solidFill>
+              </a:rPr>
+              <a:t>você</a:t>
+            </a:r>
+            <a:r>
+              <a:rPr sz="1400" b="0" i="1" dirty="0">
+                <a:solidFill>
+                  <a:srgbClr val="E5CC7A"/>
+                </a:solidFill>
+              </a:rPr>
+              <a:t> </a:t>
+            </a:r>
+            <a:r>
+              <a:rPr sz="1400" b="0" i="1" dirty="0" err="1">
+                <a:solidFill>
+                  <a:srgbClr val="E5CC7A"/>
+                </a:solidFill>
+              </a:rPr>
+              <a:t>economizar</a:t>
+            </a:r>
+            <a:r>
+              <a:rPr sz="1400" b="0" i="1" dirty="0">
+                <a:solidFill>
+                  <a:srgbClr val="E5CC7A"/>
+                </a:solidFill>
+              </a:rPr>
+              <a:t> é </a:t>
+            </a:r>
+            <a:r>
+              <a:rPr sz="1400" b="0" i="1" dirty="0" err="1">
+                <a:solidFill>
+                  <a:srgbClr val="E5CC7A"/>
+                </a:solidFill>
+              </a:rPr>
+              <a:t>inteiramente</a:t>
+            </a:r>
+            <a:r>
+              <a:rPr sz="1400" b="0" i="1" dirty="0">
+                <a:solidFill>
+                  <a:srgbClr val="E5CC7A"/>
+                </a:solidFill>
+              </a:rPr>
+              <a:t> </a:t>
+            </a:r>
+            <a:r>
+              <a:rPr sz="1400" b="0" i="1" dirty="0" err="1">
+                <a:solidFill>
+                  <a:srgbClr val="E5CC7A"/>
+                </a:solidFill>
+              </a:rPr>
+              <a:t>seu</a:t>
+            </a:r>
+            <a:endParaRPr sz="1400" b="0" i="1" dirty="0">
+              <a:solidFill>
+                <a:srgbClr val="E5CC7A"/>
+              </a:solidFill>
+            </a:endParaRPr>
+          </a:p>
+          <a:p>
+            <a:pPr algn="l">
+              <a:spcBef>
+                <a:spcPts val="1000"/>
+              </a:spcBef>
+            </a:pPr>
+            <a:r>
+              <a:rPr sz="1400" b="0" i="0" dirty="0">
+                <a:solidFill>
+                  <a:srgbClr val="8899AA"/>
+                </a:solidFill>
+              </a:rPr>
+              <a:t>Ao final do </a:t>
+            </a:r>
+            <a:r>
+              <a:rPr sz="1400" b="0" i="0" dirty="0" err="1">
+                <a:solidFill>
+                  <a:srgbClr val="8899AA"/>
+                </a:solidFill>
+              </a:rPr>
+              <a:t>processo</a:t>
+            </a:r>
+            <a:r>
+              <a:rPr sz="1400" b="0" i="0" dirty="0">
+                <a:solidFill>
+                  <a:srgbClr val="8899AA"/>
+                </a:solidFill>
+              </a:rPr>
+              <a:t>, </a:t>
+            </a:r>
+            <a:r>
+              <a:rPr sz="1400" b="0" i="0" dirty="0" err="1">
+                <a:solidFill>
+                  <a:srgbClr val="8899AA"/>
+                </a:solidFill>
+              </a:rPr>
+              <a:t>não</a:t>
+            </a:r>
+            <a:r>
+              <a:rPr sz="1400" b="0" i="0" dirty="0">
+                <a:solidFill>
+                  <a:srgbClr val="8899AA"/>
+                </a:solidFill>
+              </a:rPr>
+              <a:t> </a:t>
+            </a:r>
+            <a:r>
+              <a:rPr sz="1400" b="0" i="0" dirty="0" err="1">
+                <a:solidFill>
+                  <a:srgbClr val="8899AA"/>
+                </a:solidFill>
+              </a:rPr>
+              <a:t>cobramos</a:t>
+            </a:r>
+            <a:r>
+              <a:rPr sz="1400" b="0" i="0" dirty="0">
+                <a:solidFill>
+                  <a:srgbClr val="8899AA"/>
+                </a:solidFill>
+              </a:rPr>
+              <a:t> </a:t>
+            </a:r>
+            <a:r>
+              <a:rPr sz="1400" b="0" i="0" dirty="0" err="1">
+                <a:solidFill>
+                  <a:srgbClr val="8899AA"/>
+                </a:solidFill>
+              </a:rPr>
+              <a:t>nenhum</a:t>
+            </a:r>
+            <a:r>
+              <a:rPr sz="1400" b="0" i="0" dirty="0">
+                <a:solidFill>
+                  <a:srgbClr val="8899AA"/>
+                </a:solidFill>
+              </a:rPr>
+              <a:t> percentual </a:t>
+            </a:r>
+            <a:r>
+              <a:rPr sz="1400" b="0" i="0" dirty="0" err="1">
+                <a:solidFill>
+                  <a:srgbClr val="8899AA"/>
+                </a:solidFill>
+              </a:rPr>
+              <a:t>sobre</a:t>
+            </a:r>
+            <a:r>
+              <a:rPr sz="1400" b="0" i="0" dirty="0">
+                <a:solidFill>
+                  <a:srgbClr val="8899AA"/>
+                </a:solidFill>
+              </a:rPr>
+              <a:t> a </a:t>
+            </a:r>
+            <a:r>
+              <a:rPr sz="1400" b="0" i="0" dirty="0" err="1">
+                <a:solidFill>
+                  <a:srgbClr val="8899AA"/>
+                </a:solidFill>
+              </a:rPr>
+              <a:t>redução</a:t>
+            </a:r>
+            <a:r>
+              <a:rPr sz="1400" b="0" i="0" dirty="0">
+                <a:solidFill>
+                  <a:srgbClr val="8899AA"/>
+                </a:solidFill>
+              </a:rPr>
+              <a:t> </a:t>
+            </a:r>
+            <a:r>
+              <a:rPr sz="1400" b="0" i="0" dirty="0" err="1">
+                <a:solidFill>
+                  <a:srgbClr val="8899AA"/>
+                </a:solidFill>
+              </a:rPr>
+              <a:t>ou</a:t>
+            </a:r>
+            <a:r>
+              <a:rPr sz="1400" b="0" i="0" dirty="0">
+                <a:solidFill>
+                  <a:srgbClr val="8899AA"/>
+                </a:solidFill>
+              </a:rPr>
+              <a:t> </a:t>
+            </a:r>
+            <a:r>
+              <a:rPr sz="1400" b="0" i="0" dirty="0" err="1">
+                <a:solidFill>
+                  <a:srgbClr val="8899AA"/>
+                </a:solidFill>
+              </a:rPr>
+              <a:t>quitação</a:t>
+            </a:r>
+            <a:r>
+              <a:rPr sz="1400" b="0" i="0" dirty="0">
+                <a:solidFill>
+                  <a:srgbClr val="8899AA"/>
+                </a:solidFill>
+              </a:rPr>
+              <a:t> da </a:t>
+            </a:r>
+            <a:r>
+              <a:rPr sz="1400" b="0" i="0" dirty="0" err="1">
+                <a:solidFill>
+                  <a:srgbClr val="8899AA"/>
+                </a:solidFill>
+              </a:rPr>
+              <a:t>dívida</a:t>
+            </a:r>
+            <a:r>
+              <a:rPr sz="1400" b="0" i="0" dirty="0">
+                <a:solidFill>
+                  <a:srgbClr val="8899AA"/>
+                </a:solidFill>
+              </a:rPr>
+              <a:t>. </a:t>
+            </a:r>
+            <a:r>
+              <a:rPr sz="1400" b="0" i="0" dirty="0" err="1">
+                <a:solidFill>
+                  <a:srgbClr val="8899AA"/>
+                </a:solidFill>
+              </a:rPr>
+              <a:t>Muitos</a:t>
+            </a:r>
+            <a:r>
+              <a:rPr sz="1400" b="0" i="0" dirty="0">
+                <a:solidFill>
+                  <a:srgbClr val="8899AA"/>
+                </a:solidFill>
+              </a:rPr>
+              <a:t> </a:t>
+            </a:r>
+            <a:r>
+              <a:rPr sz="1400" b="0" i="0" dirty="0" err="1">
+                <a:solidFill>
+                  <a:srgbClr val="8899AA"/>
+                </a:solidFill>
+              </a:rPr>
+              <a:t>escritórios</a:t>
+            </a:r>
+            <a:r>
+              <a:rPr sz="1400" b="0" i="0" dirty="0">
+                <a:solidFill>
+                  <a:srgbClr val="8899AA"/>
+                </a:solidFill>
+              </a:rPr>
+              <a:t> </a:t>
+            </a:r>
+            <a:r>
+              <a:rPr sz="1400" b="0" i="0" dirty="0" err="1">
+                <a:solidFill>
+                  <a:srgbClr val="8899AA"/>
+                </a:solidFill>
+              </a:rPr>
+              <a:t>cobram</a:t>
+            </a:r>
+            <a:r>
+              <a:rPr sz="1400" b="0" i="0" dirty="0">
+                <a:solidFill>
+                  <a:srgbClr val="8899AA"/>
+                </a:solidFill>
+              </a:rPr>
+              <a:t> entre 20% a 30% do valor </a:t>
+            </a:r>
+            <a:r>
+              <a:rPr sz="1400" b="0" i="0" dirty="0" err="1">
+                <a:solidFill>
+                  <a:srgbClr val="8899AA"/>
+                </a:solidFill>
+              </a:rPr>
+              <a:t>economizado</a:t>
+            </a:r>
+            <a:r>
+              <a:rPr lang="pt-BR" sz="1400" dirty="0">
+                <a:solidFill>
+                  <a:srgbClr val="8899AA"/>
+                </a:solidFill>
+              </a:rPr>
+              <a:t>, sendo</a:t>
+            </a:r>
+            <a:r>
+              <a:rPr sz="1400" b="0" i="0" dirty="0">
+                <a:solidFill>
+                  <a:srgbClr val="8899AA"/>
+                </a:solidFill>
+              </a:rPr>
+              <a:t> </a:t>
+            </a:r>
+            <a:r>
+              <a:rPr sz="1400" b="0" i="0" dirty="0" err="1">
+                <a:solidFill>
+                  <a:srgbClr val="8899AA"/>
+                </a:solidFill>
+              </a:rPr>
+              <a:t>uma</a:t>
+            </a:r>
+            <a:r>
+              <a:rPr sz="1400" b="0" i="0" dirty="0">
+                <a:solidFill>
+                  <a:srgbClr val="8899AA"/>
+                </a:solidFill>
+              </a:rPr>
+              <a:t> </a:t>
+            </a:r>
+            <a:r>
+              <a:rPr sz="1400" b="0" i="0" dirty="0" err="1">
+                <a:solidFill>
+                  <a:srgbClr val="8899AA"/>
+                </a:solidFill>
+              </a:rPr>
+              <a:t>surpresa</a:t>
+            </a:r>
+            <a:r>
+              <a:rPr sz="1400" b="0" i="0" dirty="0">
+                <a:solidFill>
+                  <a:srgbClr val="8899AA"/>
+                </a:solidFill>
+              </a:rPr>
+              <a:t> </a:t>
+            </a:r>
+            <a:r>
+              <a:rPr sz="1400" b="0" i="0" dirty="0" err="1">
+                <a:solidFill>
+                  <a:srgbClr val="8899AA"/>
+                </a:solidFill>
+              </a:rPr>
+              <a:t>desagradável</a:t>
+            </a:r>
+            <a:r>
+              <a:rPr sz="1400" b="0" i="0" dirty="0">
+                <a:solidFill>
+                  <a:srgbClr val="8899AA"/>
+                </a:solidFill>
+              </a:rPr>
+              <a:t> no final. Na </a:t>
+            </a:r>
+            <a:r>
+              <a:rPr sz="1400" b="0" i="0" dirty="0" err="1">
+                <a:solidFill>
+                  <a:srgbClr val="8899AA"/>
+                </a:solidFill>
+              </a:rPr>
+              <a:t>BlindSafe</a:t>
+            </a:r>
+            <a:r>
+              <a:rPr sz="1400" b="0" i="0" dirty="0">
+                <a:solidFill>
+                  <a:srgbClr val="8899AA"/>
+                </a:solidFill>
+              </a:rPr>
+              <a:t>, </a:t>
+            </a:r>
+            <a:r>
+              <a:rPr sz="1400" b="0" i="0" dirty="0" err="1">
+                <a:solidFill>
+                  <a:srgbClr val="8899AA"/>
+                </a:solidFill>
+              </a:rPr>
+              <a:t>seu</a:t>
+            </a:r>
+            <a:r>
+              <a:rPr sz="1400" b="0" i="0" dirty="0">
+                <a:solidFill>
+                  <a:srgbClr val="8899AA"/>
+                </a:solidFill>
+              </a:rPr>
+              <a:t> </a:t>
+            </a:r>
+            <a:r>
+              <a:rPr sz="1400" b="0" i="0" dirty="0" err="1">
+                <a:solidFill>
+                  <a:srgbClr val="8899AA"/>
+                </a:solidFill>
+              </a:rPr>
+              <a:t>benefício</a:t>
+            </a:r>
+            <a:r>
+              <a:rPr sz="1400" b="0" i="0" dirty="0">
+                <a:solidFill>
+                  <a:srgbClr val="8899AA"/>
+                </a:solidFill>
+              </a:rPr>
+              <a:t> é 100% </a:t>
+            </a:r>
+            <a:r>
+              <a:rPr sz="1400" b="0" i="0" dirty="0" err="1">
+                <a:solidFill>
+                  <a:srgbClr val="8899AA"/>
+                </a:solidFill>
+              </a:rPr>
+              <a:t>seu</a:t>
+            </a:r>
+            <a:r>
+              <a:rPr sz="1400" b="0" i="0" dirty="0">
+                <a:solidFill>
+                  <a:srgbClr val="8899AA"/>
+                </a:solidFill>
+              </a:rPr>
+              <a:t>.</a:t>
+            </a:r>
+          </a:p>
+        </p:txBody>
+      </p:sp>
+      <p:sp>
+        <p:nvSpPr>
+          <p:cNvPr id="30" name="Rectangle 29"/>
           <p:cNvSpPr/>
           <p:nvPr/>
         </p:nvSpPr>
         <p:spPr>
           <a:xfrm>
-            <a:off x="621792" y="8211312"/>
-            <a:ext cx="6400800" cy="27432"/>
+            <a:off x="384048" y="8720000"/>
+            <a:ext cx="6793992" cy="16000"/>
           </a:xfrm>
           <a:prstGeom prst="rect">
             <a:avLst/>
           </a:prstGeom>
           <a:solidFill>
-            <a:srgbClr val="2A4070"/>
+            <a:srgbClr val="C9A84C"/>
           </a:solidFill>
           <a:ln>
             <a:noFill/>
@@ -11163,14 +12381,14 @@
       </p:sp>
       <p:sp>
         <p:nvSpPr>
-          <p:cNvPr id="39" name="TextBox 38"/>
+          <p:cNvPr id="31" name="TextBox 30"/>
           <p:cNvSpPr txBox="1"/>
           <p:nvPr/>
         </p:nvSpPr>
         <p:spPr>
           <a:xfrm>
-            <a:off x="621792" y="8348472"/>
-            <a:ext cx="6400800" cy="502920"/>
+            <a:off x="384048" y="8790000"/>
+            <a:ext cx="6793992" cy="543739"/>
           </a:xfrm>
           <a:prstGeom prst="rect">
             <a:avLst/>
@@ -11178,182 +12396,91 @@
           <a:noFill/>
         </p:spPr>
         <p:txBody>
-          <a:bodyPr wrap="square"/>
-          <a:lstStyle/>
-          <a:p>
-            <a:pPr algn="l"/>
-            <a:r>
-              <a:rPr sz="1600" b="0" i="0" dirty="0">
-                <a:solidFill>
-                  <a:srgbClr val="8899AA"/>
-                </a:solidFill>
-                <a:latin typeface="Calibri"/>
-              </a:rPr>
-              <a:t>{{OP2_ECONOMIA_LONGA}}</a:t>
-            </a:r>
-            <a:r>
-              <a:rPr sz="1600" b="0" i="0" dirty="0" err="1">
-                <a:solidFill>
-                  <a:srgbClr val="8899AA"/>
-                </a:solidFill>
-                <a:latin typeface="Calibri"/>
-              </a:rPr>
-              <a:t/>
-            </a:r>
-            <a:r>
-              <a:rPr sz="1600" b="0" i="0" dirty="0">
-                <a:solidFill>
-                  <a:srgbClr val="8899AA"/>
-                </a:solidFill>
-                <a:latin typeface="Calibri"/>
-              </a:rPr>
-              <a:t/>
-            </a:r>
-            <a:r>
-              <a:rPr sz="1600" b="0" i="0" dirty="0" err="1">
-                <a:solidFill>
-                  <a:srgbClr val="8899AA"/>
-                </a:solidFill>
-                <a:latin typeface="Calibri"/>
-              </a:rPr>
-              <a:t/>
-            </a:r>
-            <a:r>
-              <a:rPr sz="1600" b="0" i="0" dirty="0">
-                <a:solidFill>
-                  <a:srgbClr val="8899AA"/>
-                </a:solidFill>
-                <a:latin typeface="Calibri"/>
-              </a:rPr>
-              <a:t/>
-            </a:r>
-            <a:r>
-              <a:rPr sz="1600" b="0" i="0" dirty="0" err="1">
-                <a:solidFill>
-                  <a:srgbClr val="8899AA"/>
-                </a:solidFill>
-                <a:latin typeface="Calibri"/>
-              </a:rPr>
-              <a:t/>
-            </a:r>
-            <a:r>
-              <a:rPr sz="1600" b="0" i="0" dirty="0">
-                <a:solidFill>
-                  <a:srgbClr val="8899AA"/>
-                </a:solidFill>
-                <a:latin typeface="Calibri"/>
-              </a:rPr>
-              <a:t/>
-            </a:r>
-            <a:r>
-              <a:rPr sz="1600" b="0" i="0" dirty="0" err="1">
-                <a:solidFill>
-                  <a:srgbClr val="8899AA"/>
-                </a:solidFill>
-                <a:latin typeface="Calibri"/>
-              </a:rPr>
-              <a:t/>
-            </a:r>
-            <a:r>
-              <a:rPr sz="1600" b="0" i="0" dirty="0">
-                <a:solidFill>
-                  <a:srgbClr val="8899AA"/>
-                </a:solidFill>
-                <a:latin typeface="Calibri"/>
-              </a:rPr>
-              <a:t/>
-            </a:r>
-            <a:r>
-              <a:rPr sz="1600" b="0" i="0" dirty="0" err="1">
-                <a:solidFill>
-                  <a:srgbClr val="8899AA"/>
-                </a:solidFill>
-                <a:latin typeface="Calibri"/>
-              </a:rPr>
-              <a:t/>
-            </a:r>
-            <a:r>
-              <a:rPr sz="1600" b="0" i="0" dirty="0">
-                <a:solidFill>
-                  <a:srgbClr val="8899AA"/>
-                </a:solidFill>
-                <a:latin typeface="Calibri"/>
-              </a:rPr>
-              <a:t/>
-            </a:r>
-            <a:r>
-              <a:rPr sz="1600" b="0" i="0" dirty="0" err="1">
-                <a:solidFill>
-                  <a:srgbClr val="8899AA"/>
-                </a:solidFill>
-                <a:latin typeface="Calibri"/>
-              </a:rPr>
-              <a:t/>
-            </a:r>
-            <a:r>
-              <a:rPr sz="1600" b="0" i="0" dirty="0">
-                <a:solidFill>
-                  <a:srgbClr val="8899AA"/>
-                </a:solidFill>
-                <a:latin typeface="Calibri"/>
-              </a:rPr>
-              <a:t/>
-            </a:r>
-            <a:r>
-              <a:rPr sz="1600" b="0" i="0" dirty="0" err="1">
-                <a:solidFill>
-                  <a:srgbClr val="8899AA"/>
-                </a:solidFill>
-                <a:latin typeface="Calibri"/>
-              </a:rPr>
-              <a:t/>
-            </a:r>
-            <a:r>
-              <a:rPr sz="1600" b="0" i="0" dirty="0">
-                <a:solidFill>
-                  <a:srgbClr val="8899AA"/>
-                </a:solidFill>
-                <a:latin typeface="Calibri"/>
-              </a:rPr>
-              <a:t/>
-            </a:r>
-            <a:r>
-              <a:rPr sz="1600" b="0" i="0" dirty="0" err="1">
-                <a:solidFill>
-                  <a:srgbClr val="8899AA"/>
-                </a:solidFill>
-                <a:latin typeface="Calibri"/>
-              </a:rPr>
-              <a:t/>
-            </a:r>
-            <a:r>
-              <a:rPr sz="1600" b="0" i="0" dirty="0">
-                <a:solidFill>
-                  <a:srgbClr val="8899AA"/>
-                </a:solidFill>
-                <a:latin typeface="Calibri"/>
-              </a:rPr>
-              <a:t/>
-            </a:r>
-          </a:p>
-        </p:txBody>
-      </p:sp>
-      <p:sp>
-        <p:nvSpPr>
-          <p:cNvPr id="40" name="Rectangle 39"/>
+          <a:bodyPr wrap="square" lIns="0" tIns="0" rIns="0" bIns="0">
+            <a:spAutoFit/>
+          </a:bodyPr>
+          <a:lstStyle/>
+          <a:p>
+            <a:pPr algn="ctr"/>
+            <a:r>
+              <a:rPr b="0" i="1" dirty="0">
+                <a:solidFill>
+                  <a:srgbClr val="E5CC7A"/>
+                </a:solidFill>
+              </a:rPr>
+              <a:t>"</a:t>
+            </a:r>
+            <a:r>
+              <a:rPr lang="pt-BR" b="0" i="1" dirty="0">
+                <a:solidFill>
+                  <a:srgbClr val="E5CC7A"/>
+                </a:solidFill>
+              </a:rPr>
+              <a:t>Sua tranquilidade é o nosso maior objetivo</a:t>
+            </a:r>
+            <a:r>
+              <a:rPr b="0" i="1" dirty="0">
+                <a:solidFill>
+                  <a:srgbClr val="E5CC7A"/>
+                </a:solidFill>
+              </a:rPr>
+              <a:t>"</a:t>
+            </a:r>
+          </a:p>
+          <a:p>
+            <a:pPr algn="ctr">
+              <a:spcBef>
+                <a:spcPts val="1000"/>
+              </a:spcBef>
+            </a:pPr>
+            <a:r>
+              <a:rPr sz="900" b="0" i="0" dirty="0">
+                <a:solidFill>
+                  <a:srgbClr val="8899AA"/>
+                </a:solidFill>
+              </a:rPr>
+              <a:t>— Equipe </a:t>
+            </a:r>
+            <a:r>
+              <a:rPr sz="900" b="0" i="0" dirty="0" err="1">
+                <a:solidFill>
+                  <a:srgbClr val="8899AA"/>
+                </a:solidFill>
+              </a:rPr>
+              <a:t>BlindSafe</a:t>
+            </a:r>
+            <a:r>
+              <a:rPr lang="pt-BR" sz="900" b="0" i="0" dirty="0">
+                <a:solidFill>
+                  <a:srgbClr val="8899AA"/>
+                </a:solidFill>
+              </a:rPr>
+              <a:t> soluções financeiras </a:t>
+            </a:r>
+            <a:endParaRPr sz="900" b="0" i="0" dirty="0">
+              <a:solidFill>
+                <a:srgbClr val="8899AA"/>
+              </a:solidFill>
+            </a:endParaRPr>
+          </a:p>
+        </p:txBody>
+      </p:sp>
+      <p:sp>
+        <p:nvSpPr>
+          <p:cNvPr id="32" name="Rectangle 31"/>
           <p:cNvSpPr/>
           <p:nvPr/>
         </p:nvSpPr>
         <p:spPr>
           <a:xfrm>
-            <a:off x="621792" y="9098280"/>
-            <a:ext cx="6400800" cy="27432"/>
+            <a:off x="0" y="10341864"/>
+            <a:ext cx="7562850" cy="18000"/>
           </a:xfrm>
           <a:prstGeom prst="rect">
             <a:avLst/>
           </a:prstGeom>
           <a:solidFill>
-            <a:srgbClr val="2A4070"/>
+            <a:srgbClr val="C9A84C"/>
           </a:solidFill>
           <a:ln>
             <a:noFill/>
@@ -11382,40 +12509,16 @@
           </a:p>
         </p:txBody>
       </p:sp>
-      <p:pic>
-        <p:nvPicPr>
-          <p:cNvPr id="41" name="Picture 40" descr="image5.png"/>
-          <p:cNvPicPr>
-            <a:picLocks noChangeAspect="1"/>
-          </p:cNvPicPr>
-          <p:nvPr/>
-        </p:nvPicPr>
-        <p:blipFill>
-          <a:blip r:embed="rId2"/>
-          <a:stretch>
-            <a:fillRect/>
-          </a:stretch>
-        </p:blipFill>
-        <p:spPr>
-          <a:xfrm>
-            <a:off x="621792" y="9262872"/>
-            <a:ext cx="292608" cy="292608"/>
-          </a:xfrm>
-          <a:prstGeom prst="rect">
-            <a:avLst/>
-          </a:prstGeom>
-        </p:spPr>
-      </p:pic>
-      <p:sp>
-        <p:nvSpPr>
-          <p:cNvPr id="42" name="TextBox 41"/>
+      <p:sp>
+        <p:nvSpPr>
+          <p:cNvPr id="33" name="TextBox 32"/>
           <p:cNvSpPr txBox="1"/>
           <p:nvPr/>
         </p:nvSpPr>
         <p:spPr>
           <a:xfrm>
-            <a:off x="1033272" y="9244584"/>
-            <a:ext cx="2834640" cy="548640"/>
+            <a:off x="384048" y="10371864"/>
+            <a:ext cx="6793992" cy="240000"/>
           </a:xfrm>
           <a:prstGeom prst="rect">
             <a:avLst/>
@@ -11423,335 +12526,19 @@
           <a:noFill/>
         </p:spPr>
         <p:txBody>
-          <a:bodyPr wrap="square"/>
-          <a:lstStyle/>
-          <a:p>
-            <a:pPr algn="l"/>
-            <a:r>
-              <a:rPr sz="1400" b="0" i="0" dirty="0" err="1">
-                <a:solidFill>
-                  <a:srgbClr val="8899AA"/>
-                </a:solidFill>
-                <a:latin typeface="Calibri"/>
-              </a:rPr>
-              <a:t>Melhor</a:t>
-            </a:r>
-            <a:r>
-              <a:rPr sz="1400" b="0" i="0" dirty="0">
-                <a:solidFill>
-                  <a:srgbClr val="8899AA"/>
-                </a:solidFill>
-                <a:latin typeface="Calibri"/>
-              </a:rPr>
-              <a:t> </a:t>
-            </a:r>
-            <a:r>
-              <a:rPr sz="1400" b="0" i="0" dirty="0" err="1">
-                <a:solidFill>
-                  <a:srgbClr val="8899AA"/>
-                </a:solidFill>
-                <a:latin typeface="Calibri"/>
-              </a:rPr>
-              <a:t>custo-benefício</a:t>
-            </a:r>
-            <a:r>
-              <a:rPr sz="1400" b="0" i="0" dirty="0">
-                <a:solidFill>
-                  <a:srgbClr val="8899AA"/>
-                </a:solidFill>
-                <a:latin typeface="Calibri"/>
-              </a:rPr>
-              <a:t> </a:t>
-            </a:r>
-            <a:r>
-              <a:rPr sz="1400" b="0" i="0" dirty="0" err="1">
-                <a:solidFill>
-                  <a:srgbClr val="8899AA"/>
-                </a:solidFill>
-                <a:latin typeface="Calibri"/>
-              </a:rPr>
-              <a:t>desta</a:t>
-            </a:r>
-            <a:r>
-              <a:rPr sz="1400" b="0" i="0" dirty="0">
-                <a:solidFill>
-                  <a:srgbClr val="8899AA"/>
-                </a:solidFill>
-                <a:latin typeface="Calibri"/>
-              </a:rPr>
-              <a:t> </a:t>
-            </a:r>
-            <a:r>
-              <a:rPr sz="1400" b="0" i="0" dirty="0" err="1">
-                <a:solidFill>
-                  <a:srgbClr val="8899AA"/>
-                </a:solidFill>
-                <a:latin typeface="Calibri"/>
-              </a:rPr>
-              <a:t>proposta</a:t>
-            </a:r>
-            <a:endParaRPr sz="1400" b="0" i="0" dirty="0">
-              <a:solidFill>
-                <a:srgbClr val="8899AA"/>
-              </a:solidFill>
-              <a:latin typeface="Calibri"/>
-            </a:endParaRPr>
-          </a:p>
-        </p:txBody>
-      </p:sp>
-      <p:pic>
-        <p:nvPicPr>
-          <p:cNvPr id="43" name="Picture 42" descr="image5.png"/>
-          <p:cNvPicPr>
-            <a:picLocks noChangeAspect="1"/>
-          </p:cNvPicPr>
-          <p:nvPr/>
-        </p:nvPicPr>
-        <p:blipFill>
-          <a:blip r:embed="rId2"/>
-          <a:stretch>
-            <a:fillRect/>
-          </a:stretch>
-        </p:blipFill>
-        <p:spPr>
-          <a:xfrm>
-            <a:off x="3959352" y="9262872"/>
-            <a:ext cx="292608" cy="292608"/>
-          </a:xfrm>
-          <a:prstGeom prst="rect">
-            <a:avLst/>
-          </a:prstGeom>
-        </p:spPr>
-      </p:pic>
-      <p:sp>
-        <p:nvSpPr>
-          <p:cNvPr id="44" name="TextBox 43"/>
-          <p:cNvSpPr txBox="1"/>
-          <p:nvPr/>
-        </p:nvSpPr>
-        <p:spPr>
-          <a:xfrm>
-            <a:off x="4370832" y="9244584"/>
-            <a:ext cx="2834640" cy="548640"/>
-          </a:xfrm>
-          <a:prstGeom prst="rect">
-            <a:avLst/>
-          </a:prstGeom>
-          <a:noFill/>
-        </p:spPr>
-        <p:txBody>
-          <a:bodyPr wrap="square"/>
-          <a:lstStyle/>
-          <a:p>
-            <a:pPr algn="l"/>
-            <a:r>
-              <a:rPr sz="1400" b="0" i="0" dirty="0" err="1">
-                <a:solidFill>
-                  <a:srgbClr val="8899AA"/>
-                </a:solidFill>
-                <a:latin typeface="Calibri"/>
-              </a:rPr>
-              <a:t>{{OP2_PARCELAS_SEM_JUROS}}</a:t>
-            </a:r>
-            <a:r>
-              <a:rPr sz="1400" b="0" i="0" dirty="0">
-                <a:solidFill>
-                  <a:srgbClr val="8899AA"/>
-                </a:solidFill>
-                <a:latin typeface="Calibri"/>
-              </a:rPr>
-              <a:t/>
-            </a:r>
-            <a:r>
-              <a:rPr sz="1400" b="0" i="0" dirty="0" err="1">
-                <a:solidFill>
-                  <a:srgbClr val="8899AA"/>
-                </a:solidFill>
-                <a:latin typeface="Calibri"/>
-              </a:rPr>
-              <a:t/>
-            </a:r>
-            <a:r>
-              <a:rPr sz="1400" b="0" i="0" dirty="0">
-                <a:solidFill>
-                  <a:srgbClr val="8899AA"/>
-                </a:solidFill>
-                <a:latin typeface="Calibri"/>
-              </a:rPr>
-              <a:t/>
-            </a:r>
-            <a:r>
-              <a:rPr sz="1400" b="0" i="0" dirty="0" err="1">
-                <a:solidFill>
-                  <a:srgbClr val="8899AA"/>
-                </a:solidFill>
-                <a:latin typeface="Calibri"/>
-              </a:rPr>
-              <a:t/>
-            </a:r>
-            <a:r>
-              <a:rPr sz="1400" b="0" i="0" dirty="0">
-                <a:solidFill>
-                  <a:srgbClr val="8899AA"/>
-                </a:solidFill>
-                <a:latin typeface="Calibri"/>
-              </a:rPr>
-              <a:t/>
-            </a:r>
-            <a:r>
-              <a:rPr sz="1400" b="0" i="0" dirty="0" err="1">
-                <a:solidFill>
-                  <a:srgbClr val="8899AA"/>
-                </a:solidFill>
-                <a:latin typeface="Calibri"/>
-              </a:rPr>
-              <a:t/>
-            </a:r>
-            <a:r>
-              <a:rPr sz="1400" b="0" i="0" dirty="0">
-                <a:solidFill>
-                  <a:srgbClr val="8899AA"/>
-                </a:solidFill>
-                <a:latin typeface="Calibri"/>
-              </a:rPr>
-              <a:t/>
-            </a:r>
-            <a:r>
-              <a:rPr sz="1400" b="0" i="0" dirty="0" err="1">
-                <a:solidFill>
-                  <a:srgbClr val="8899AA"/>
-                </a:solidFill>
-                <a:latin typeface="Calibri"/>
-              </a:rPr>
-              <a:t/>
-            </a:r>
-            <a:endParaRPr sz="1400" b="0" i="0" dirty="0">
-              <a:solidFill>
-                <a:srgbClr val="8899AA"/>
-              </a:solidFill>
-              <a:latin typeface="Calibri"/>
-            </a:endParaRPr>
-          </a:p>
-        </p:txBody>
-      </p:sp>
-      <p:sp>
-        <p:nvSpPr>
-          <p:cNvPr id="45" name="Rectangle 44"/>
-          <p:cNvSpPr/>
-          <p:nvPr/>
-        </p:nvSpPr>
-        <p:spPr>
-          <a:xfrm>
-            <a:off x="384048" y="10341864"/>
-            <a:ext cx="6793992" cy="18288"/>
-          </a:xfrm>
-          <a:prstGeom prst="rect">
-            <a:avLst/>
-          </a:prstGeom>
-          <a:solidFill>
-            <a:srgbClr val="EBEBEB"/>
-          </a:solidFill>
-          <a:ln>
-            <a:noFill/>
-          </a:ln>
-        </p:spPr>
-        <p:style>
-          <a:lnRef idx="1">
-            <a:schemeClr val="accent1"/>
-          </a:lnRef>
-          <a:fillRef idx="3">
-            <a:schemeClr val="accent1"/>
-          </a:fillRef>
-          <a:effectRef idx="2">
-            <a:schemeClr val="accent1"/>
-          </a:effectRef>
-          <a:fontRef idx="minor">
-            <a:schemeClr val="lt1"/>
-          </a:fontRef>
-        </p:style>
-        <p:txBody>
-          <a:bodyPr rtlCol="0" anchor="ctr"/>
+          <a:bodyPr wrap="square" lIns="0" tIns="0" rIns="0" bIns="0">
+            <a:spAutoFit/>
+          </a:bodyPr>
           <a:lstStyle/>
           <a:p>
             <a:pPr algn="ctr"/>
-            <a:endParaRPr/>
-          </a:p>
-        </p:txBody>
-      </p:sp>
-      <p:sp>
-        <p:nvSpPr>
-          <p:cNvPr id="46" name="TextBox 45"/>
-          <p:cNvSpPr txBox="1"/>
-          <p:nvPr/>
-        </p:nvSpPr>
-        <p:spPr>
-          <a:xfrm>
-            <a:off x="384048" y="10369296"/>
-            <a:ext cx="6793992" cy="237744"/>
-          </a:xfrm>
-          <a:prstGeom prst="rect">
-            <a:avLst/>
-          </a:prstGeom>
-          <a:noFill/>
-        </p:spPr>
-        <p:txBody>
-          <a:bodyPr wrap="square"/>
-          <a:lstStyle/>
-          <a:p>
-            <a:pPr algn="ctr"/>
-            <a:r>
-              <a:rPr sz="1100" b="0" i="0" dirty="0" err="1">
-                <a:solidFill>
-                  <a:srgbClr val="8899AA"/>
-                </a:solidFill>
-                <a:latin typeface="Calibri"/>
-              </a:rPr>
-              <a:t>BlindSafe</a:t>
-            </a:r>
-            <a:r>
-              <a:rPr sz="1100" b="0" i="0" dirty="0">
-                <a:solidFill>
-                  <a:srgbClr val="8899AA"/>
-                </a:solidFill>
-                <a:latin typeface="Calibri"/>
-              </a:rPr>
-              <a:t> </a:t>
-            </a:r>
-            <a:r>
-              <a:rPr sz="1100" b="0" i="0" dirty="0" err="1">
-                <a:solidFill>
-                  <a:srgbClr val="8899AA"/>
-                </a:solidFill>
-                <a:latin typeface="Calibri"/>
-              </a:rPr>
-              <a:t>Soluções</a:t>
-            </a:r>
-            <a:r>
-              <a:rPr sz="1100" b="0" i="0" dirty="0">
-                <a:solidFill>
-                  <a:srgbClr val="8899AA"/>
-                </a:solidFill>
-                <a:latin typeface="Calibri"/>
-              </a:rPr>
-              <a:t> </a:t>
-            </a:r>
-            <a:r>
-              <a:rPr sz="1100" b="0" i="0" dirty="0" err="1">
-                <a:solidFill>
-                  <a:srgbClr val="8899AA"/>
-                </a:solidFill>
-                <a:latin typeface="Calibri"/>
-              </a:rPr>
-              <a:t>Financeiras</a:t>
-            </a:r>
-            <a:r>
-              <a:rPr sz="1100" b="0" i="0" dirty="0">
-                <a:solidFill>
-                  <a:srgbClr val="8899AA"/>
-                </a:solidFill>
-                <a:latin typeface="Calibri"/>
-              </a:rPr>
-              <a:t>  |  contato@blindsafe.com.br  |  (21) 3437-5022</a:t>
+            <a:r>
+              <a:rPr sz="800" b="0" i="0">
+                <a:solidFill>
+                  <a:srgbClr val="8899AA"/>
+                </a:solidFill>
+              </a:rPr>
+              <a:t>BlindSafe Soluções Financeiras  |  contato@blindsafe.com.br  |  (21) 3437-5022</a:t>
             </a:r>
           </a:p>
         </p:txBody>
@@ -13008,6 +13795,40 @@
           </a:p>
         </p:txBody>
       </p:sp>
+      <p:sp>
+        <p:nvSpPr>
+          <p:cNvPr id="28" name="TextBox 27"/>
+          <p:cNvSpPr txBox="1"/>
+          <p:nvPr/>
+        </p:nvSpPr>
+        <p:spPr>
+          <a:xfrm>
+            <a:off x="685800" y="3340000"/>
+            <a:ext cx="5943600" cy="380000"/>
+          </a:xfrm>
+          <a:prstGeom prst="rect">
+            <a:avLst/>
+          </a:prstGeom>
+          <a:noFill/>
+        </p:spPr>
+        <p:txBody>
+          <a:bodyPr wrap="square" lIns="0" tIns="0" rIns="0" bIns="0">
+            <a:spAutoFit/>
+          </a:bodyPr>
+          <a:lstStyle/>
+          <a:p>
+            <a:pPr algn="l"/>
+            <a:r>
+              <a:rPr sz="1000" b="0" i="1">
+                <a:solidFill>
+                  <a:srgbClr val="C9A84C"/>
+                </a:solidFill>
+              </a:rPr>
+              <a:t>Representa apenas {{PERC_OP1}} do valor total da causa</a:t>
+            </a:r>
+          </a:p>
+        </p:txBody>
+      </p:sp>
     </p:spTree>
   </p:cSld>
   <p:clrMapOvr>
@@ -13731,15 +14552,6 @@
               </a:rPr>
               <a:t>{{OP2_ATE_PARCELAS}}</a:t>
             </a:r>
-            <a:r>
-              <a:rPr sz="1600" b="0" i="0" dirty="0">
-                <a:solidFill>
-                  <a:srgbClr val="8899AA"/>
-                </a:solidFill>
-                <a:latin typeface="Calibri"/>
-              </a:rPr>
-              <a:t/>
-            </a:r>
           </a:p>
         </p:txBody>
       </p:sp>
@@ -13882,66 +14694,6 @@
               <a:t>{{OP2_TOTAL}}
 {{OP2_PARCELAS_MENSAIS}}</a:t>
             </a:r>
-            <a:r>
-              <a:rPr sz="1100" b="0" i="0" dirty="0">
-                <a:solidFill>
-                  <a:srgbClr val="8899AA"/>
-                </a:solidFill>
-                <a:latin typeface="Calibri"/>
-              </a:rPr>
-              <a:t/>
-            </a:r>
-            <a:r>
-              <a:rPr sz="1400" b="0" i="0" dirty="0" err="1">
-                <a:solidFill>
-                  <a:srgbClr val="8899AA"/>
-                </a:solidFill>
-                <a:latin typeface="Calibri"/>
-              </a:rPr>
-              <a:t/>
-            </a:r>
-            <a:r>
-              <a:rPr sz="1400" b="0" i="0" dirty="0">
-                <a:solidFill>
-                  <a:srgbClr val="8899AA"/>
-                </a:solidFill>
-                <a:latin typeface="Calibri"/>
-              </a:rPr>
-              <a:t/>
-            </a:r>
-            <a:r>
-              <a:rPr sz="1400" b="0" i="0" dirty="0" err="1">
-                <a:solidFill>
-                  <a:srgbClr val="8899AA"/>
-                </a:solidFill>
-                <a:latin typeface="Calibri"/>
-              </a:rPr>
-              <a:t/>
-            </a:r>
-            <a:r>
-              <a:rPr sz="1400" b="0" i="0" dirty="0">
-                <a:solidFill>
-                  <a:srgbClr val="8899AA"/>
-                </a:solidFill>
-                <a:latin typeface="Calibri"/>
-              </a:rPr>
-              <a:t/>
-            </a:r>
-            <a:r>
-              <a:rPr sz="1400" b="0" i="0" dirty="0" err="1">
-                <a:solidFill>
-                  <a:srgbClr val="8899AA"/>
-                </a:solidFill>
-                <a:latin typeface="Calibri"/>
-              </a:rPr>
-              <a:t/>
-            </a:r>
-            <a:endParaRPr sz="1400" b="0" i="0" dirty="0">
-              <a:solidFill>
-                <a:srgbClr val="8899AA"/>
-              </a:solidFill>
-              <a:latin typeface="Calibri"/>
-            </a:endParaRPr>
           </a:p>
         </p:txBody>
       </p:sp>
@@ -14742,6 +15494,40 @@
                 <a:latin typeface="Calibri"/>
               </a:rPr>
               <a:t>  |  contato@blindsafe.com.br  |  (21) 3437-5022</a:t>
+            </a:r>
+          </a:p>
+        </p:txBody>
+      </p:sp>
+      <p:sp>
+        <p:nvSpPr>
+          <p:cNvPr id="34" name="TextBox 33"/>
+          <p:cNvSpPr txBox="1"/>
+          <p:nvPr/>
+        </p:nvSpPr>
+        <p:spPr>
+          <a:xfrm>
+            <a:off x="594360" y="4480000"/>
+            <a:ext cx="3081527" cy="200000"/>
+          </a:xfrm>
+          <a:prstGeom prst="rect">
+            <a:avLst/>
+          </a:prstGeom>
+          <a:noFill/>
+        </p:spPr>
+        <p:txBody>
+          <a:bodyPr wrap="square" lIns="0" tIns="0" rIns="0" bIns="0">
+            <a:spAutoFit/>
+          </a:bodyPr>
+          <a:lstStyle/>
+          <a:p>
+            <a:pPr algn="l"/>
+            <a:r>
+              <a:rPr sz="900" b="0" i="1">
+                <a:solidFill>
+                  <a:srgbClr val="C9A84C"/>
+                </a:solidFill>
+              </a:rPr>
+              <a:t>≈ {{PERC_OP2_AV}} do valor da causa</a:t>
             </a:r>
           </a:p>
         </p:txBody>

</xml_diff>

<commit_message>
fix: procuração extrajudicial com formatação unificada e sem página em branco
- Corrige margens: contrato e procuração agora usam a mesma formatação
  (antes cada um mantinha a própria margem, parecendo folhas coladas)
- Remove overflow de página em branco entre contrato e procuração,
  causado por espaçamento excessivo nos templates antes da assinatura
- Compacta a procuração extrajudicial para caber em 1 página
- Corrige alinhamento do parágrafo OUTORGANTE na versão PJ
- Adiciona templates procuracao_extrajudicial.docx e _pj.docx
- Remove funções de merge de PDF que ficaram sem uso após simplificação

Co-Authored-By: Claude Sonnet 4.6 <noreply@anthropic.com>
</commit_message>
<xml_diff>
--- a/templates/proposta.pptx
+++ b/templates/proposta.pptx
@@ -434,7 +434,7 @@
           <a:p>
             <a:fld id="{5BCAD085-E8A6-8845-BD4E-CB4CCA059FC4}" type="datetimeFigureOut">
               <a:rPr lang="en-US" smtClean="0"/>
-              <a:t>6/28/2026</a:t>
+              <a:t>7/14/2026</a:t>
             </a:fld>
             <a:endParaRPr lang="en-US"/>
           </a:p>
@@ -602,7 +602,7 @@
           <a:p>
             <a:fld id="{5BCAD085-E8A6-8845-BD4E-CB4CCA059FC4}" type="datetimeFigureOut">
               <a:rPr lang="en-US" smtClean="0"/>
-              <a:t>6/28/2026</a:t>
+              <a:t>7/14/2026</a:t>
             </a:fld>
             <a:endParaRPr lang="en-US"/>
           </a:p>
@@ -780,7 +780,7 @@
           <a:p>
             <a:fld id="{5BCAD085-E8A6-8845-BD4E-CB4CCA059FC4}" type="datetimeFigureOut">
               <a:rPr lang="en-US" smtClean="0"/>
-              <a:t>6/28/2026</a:t>
+              <a:t>7/14/2026</a:t>
             </a:fld>
             <a:endParaRPr lang="en-US"/>
           </a:p>
@@ -948,7 +948,7 @@
           <a:p>
             <a:fld id="{5BCAD085-E8A6-8845-BD4E-CB4CCA059FC4}" type="datetimeFigureOut">
               <a:rPr lang="en-US" smtClean="0"/>
-              <a:t>6/28/2026</a:t>
+              <a:t>7/14/2026</a:t>
             </a:fld>
             <a:endParaRPr lang="en-US"/>
           </a:p>
@@ -1193,7 +1193,7 @@
           <a:p>
             <a:fld id="{5BCAD085-E8A6-8845-BD4E-CB4CCA059FC4}" type="datetimeFigureOut">
               <a:rPr lang="en-US" smtClean="0"/>
-              <a:t>6/28/2026</a:t>
+              <a:t>7/14/2026</a:t>
             </a:fld>
             <a:endParaRPr lang="en-US"/>
           </a:p>
@@ -1478,7 +1478,7 @@
           <a:p>
             <a:fld id="{5BCAD085-E8A6-8845-BD4E-CB4CCA059FC4}" type="datetimeFigureOut">
               <a:rPr lang="en-US" smtClean="0"/>
-              <a:t>6/28/2026</a:t>
+              <a:t>7/14/2026</a:t>
             </a:fld>
             <a:endParaRPr lang="en-US"/>
           </a:p>
@@ -1897,7 +1897,7 @@
           <a:p>
             <a:fld id="{5BCAD085-E8A6-8845-BD4E-CB4CCA059FC4}" type="datetimeFigureOut">
               <a:rPr lang="en-US" smtClean="0"/>
-              <a:t>6/28/2026</a:t>
+              <a:t>7/14/2026</a:t>
             </a:fld>
             <a:endParaRPr lang="en-US"/>
           </a:p>
@@ -2014,7 +2014,7 @@
           <a:p>
             <a:fld id="{5BCAD085-E8A6-8845-BD4E-CB4CCA059FC4}" type="datetimeFigureOut">
               <a:rPr lang="en-US" smtClean="0"/>
-              <a:t>6/28/2026</a:t>
+              <a:t>7/14/2026</a:t>
             </a:fld>
             <a:endParaRPr lang="en-US"/>
           </a:p>
@@ -2109,7 +2109,7 @@
           <a:p>
             <a:fld id="{5BCAD085-E8A6-8845-BD4E-CB4CCA059FC4}" type="datetimeFigureOut">
               <a:rPr lang="en-US" smtClean="0"/>
-              <a:t>6/28/2026</a:t>
+              <a:t>7/14/2026</a:t>
             </a:fld>
             <a:endParaRPr lang="en-US"/>
           </a:p>
@@ -2384,7 +2384,7 @@
           <a:p>
             <a:fld id="{5BCAD085-E8A6-8845-BD4E-CB4CCA059FC4}" type="datetimeFigureOut">
               <a:rPr lang="en-US" smtClean="0"/>
-              <a:t>6/28/2026</a:t>
+              <a:t>7/14/2026</a:t>
             </a:fld>
             <a:endParaRPr lang="en-US"/>
           </a:p>
@@ -2636,7 +2636,7 @@
           <a:p>
             <a:fld id="{5BCAD085-E8A6-8845-BD4E-CB4CCA059FC4}" type="datetimeFigureOut">
               <a:rPr lang="en-US" smtClean="0"/>
-              <a:t>6/28/2026</a:t>
+              <a:t>7/14/2026</a:t>
             </a:fld>
             <a:endParaRPr lang="en-US"/>
           </a:p>
@@ -2847,7 +2847,7 @@
           <a:p>
             <a:fld id="{5BCAD085-E8A6-8845-BD4E-CB4CCA059FC4}" type="datetimeFigureOut">
               <a:rPr lang="en-US" smtClean="0"/>
-              <a:t>6/28/2026</a:t>
+              <a:t>7/14/2026</a:t>
             </a:fld>
             <a:endParaRPr lang="en-US"/>
           </a:p>
@@ -9958,7 +9958,7 @@
         <p:spPr>
           <a:xfrm>
             <a:off x="464048" y="871979"/>
-            <a:ext cx="6393992" cy="220000"/>
+            <a:ext cx="6393992" cy="369332"/>
           </a:xfrm>
           <a:prstGeom prst="rect">
             <a:avLst/>
@@ -9973,7 +9973,7 @@
           <a:p>
             <a:pPr algn="l"/>
             <a:r>
-              <a:rPr sz="2800" b="1" i="0" dirty="0">
+              <a:rPr sz="2400" b="1" i="0" dirty="0">
                 <a:solidFill>
                   <a:srgbClr val="C9A84C"/>
                 </a:solidFill>
@@ -10186,7 +10186,7 @@
         <p:spPr>
           <a:xfrm>
             <a:off x="464048" y="1910000"/>
-            <a:ext cx="3136996" cy="380000"/>
+            <a:ext cx="3136996" cy="492443"/>
           </a:xfrm>
           <a:prstGeom prst="rect">
             <a:avLst/>
@@ -10201,7 +10201,7 @@
           <a:p>
             <a:pPr algn="l"/>
             <a:r>
-              <a:rPr sz="3600" b="1" i="0" dirty="0">
+              <a:rPr sz="3200" b="1" i="0" dirty="0">
                 <a:solidFill>
                   <a:srgbClr val="E5CC7A"/>
                 </a:solidFill>
@@ -10372,7 +10372,7 @@
         <p:spPr>
           <a:xfrm>
             <a:off x="3961044" y="1910000"/>
-            <a:ext cx="3136996" cy="380000"/>
+            <a:ext cx="3136996" cy="492443"/>
           </a:xfrm>
           <a:prstGeom prst="rect">
             <a:avLst/>
@@ -10387,7 +10387,7 @@
           <a:p>
             <a:pPr algn="l"/>
             <a:r>
-              <a:rPr sz="3600" b="1" i="0" dirty="0">
+              <a:rPr sz="3200" b="1" i="0" dirty="0">
                 <a:solidFill>
                   <a:srgbClr val="E5CC7A"/>
                 </a:solidFill>
@@ -10685,7 +10685,7 @@
           <a:p>
             <a:pPr algn="ctr"/>
             <a:r>
-              <a:rPr sz="1800" b="1" i="0">
+              <a:rPr sz="1800" b="1" i="0" dirty="0">
                 <a:solidFill>
                   <a:srgbClr val="182D56"/>
                 </a:solidFill>

</xml_diff>

<commit_message>
chore: edições manuais nos templates (espaçamento e separação procuração)
- Remove espaçamento excessivo antes da assinatura em emprestimo/veiculo/rural
- Separa procuração judicial (procuracao.docx/_pj.docx) da extrajudicial
- Adiciona templates procuracao_extrajudicial.docx e _pj.docx
</commit_message>
<xml_diff>
--- a/templates/proposta.pptx
+++ b/templates/proposta.pptx
@@ -434,7 +434,7 @@
           <a:p>
             <a:fld id="{5BCAD085-E8A6-8845-BD4E-CB4CCA059FC4}" type="datetimeFigureOut">
               <a:rPr lang="en-US" smtClean="0"/>
-              <a:t>6/28/2026</a:t>
+              <a:t>7/14/2026</a:t>
             </a:fld>
             <a:endParaRPr lang="en-US"/>
           </a:p>
@@ -602,7 +602,7 @@
           <a:p>
             <a:fld id="{5BCAD085-E8A6-8845-BD4E-CB4CCA059FC4}" type="datetimeFigureOut">
               <a:rPr lang="en-US" smtClean="0"/>
-              <a:t>6/28/2026</a:t>
+              <a:t>7/14/2026</a:t>
             </a:fld>
             <a:endParaRPr lang="en-US"/>
           </a:p>
@@ -780,7 +780,7 @@
           <a:p>
             <a:fld id="{5BCAD085-E8A6-8845-BD4E-CB4CCA059FC4}" type="datetimeFigureOut">
               <a:rPr lang="en-US" smtClean="0"/>
-              <a:t>6/28/2026</a:t>
+              <a:t>7/14/2026</a:t>
             </a:fld>
             <a:endParaRPr lang="en-US"/>
           </a:p>
@@ -948,7 +948,7 @@
           <a:p>
             <a:fld id="{5BCAD085-E8A6-8845-BD4E-CB4CCA059FC4}" type="datetimeFigureOut">
               <a:rPr lang="en-US" smtClean="0"/>
-              <a:t>6/28/2026</a:t>
+              <a:t>7/14/2026</a:t>
             </a:fld>
             <a:endParaRPr lang="en-US"/>
           </a:p>
@@ -1193,7 +1193,7 @@
           <a:p>
             <a:fld id="{5BCAD085-E8A6-8845-BD4E-CB4CCA059FC4}" type="datetimeFigureOut">
               <a:rPr lang="en-US" smtClean="0"/>
-              <a:t>6/28/2026</a:t>
+              <a:t>7/14/2026</a:t>
             </a:fld>
             <a:endParaRPr lang="en-US"/>
           </a:p>
@@ -1478,7 +1478,7 @@
           <a:p>
             <a:fld id="{5BCAD085-E8A6-8845-BD4E-CB4CCA059FC4}" type="datetimeFigureOut">
               <a:rPr lang="en-US" smtClean="0"/>
-              <a:t>6/28/2026</a:t>
+              <a:t>7/14/2026</a:t>
             </a:fld>
             <a:endParaRPr lang="en-US"/>
           </a:p>
@@ -1897,7 +1897,7 @@
           <a:p>
             <a:fld id="{5BCAD085-E8A6-8845-BD4E-CB4CCA059FC4}" type="datetimeFigureOut">
               <a:rPr lang="en-US" smtClean="0"/>
-              <a:t>6/28/2026</a:t>
+              <a:t>7/14/2026</a:t>
             </a:fld>
             <a:endParaRPr lang="en-US"/>
           </a:p>
@@ -2014,7 +2014,7 @@
           <a:p>
             <a:fld id="{5BCAD085-E8A6-8845-BD4E-CB4CCA059FC4}" type="datetimeFigureOut">
               <a:rPr lang="en-US" smtClean="0"/>
-              <a:t>6/28/2026</a:t>
+              <a:t>7/14/2026</a:t>
             </a:fld>
             <a:endParaRPr lang="en-US"/>
           </a:p>
@@ -2109,7 +2109,7 @@
           <a:p>
             <a:fld id="{5BCAD085-E8A6-8845-BD4E-CB4CCA059FC4}" type="datetimeFigureOut">
               <a:rPr lang="en-US" smtClean="0"/>
-              <a:t>6/28/2026</a:t>
+              <a:t>7/14/2026</a:t>
             </a:fld>
             <a:endParaRPr lang="en-US"/>
           </a:p>
@@ -2384,7 +2384,7 @@
           <a:p>
             <a:fld id="{5BCAD085-E8A6-8845-BD4E-CB4CCA059FC4}" type="datetimeFigureOut">
               <a:rPr lang="en-US" smtClean="0"/>
-              <a:t>6/28/2026</a:t>
+              <a:t>7/14/2026</a:t>
             </a:fld>
             <a:endParaRPr lang="en-US"/>
           </a:p>
@@ -2636,7 +2636,7 @@
           <a:p>
             <a:fld id="{5BCAD085-E8A6-8845-BD4E-CB4CCA059FC4}" type="datetimeFigureOut">
               <a:rPr lang="en-US" smtClean="0"/>
-              <a:t>6/28/2026</a:t>
+              <a:t>7/14/2026</a:t>
             </a:fld>
             <a:endParaRPr lang="en-US"/>
           </a:p>
@@ -2847,7 +2847,7 @@
           <a:p>
             <a:fld id="{5BCAD085-E8A6-8845-BD4E-CB4CCA059FC4}" type="datetimeFigureOut">
               <a:rPr lang="en-US" smtClean="0"/>
-              <a:t>6/28/2026</a:t>
+              <a:t>7/14/2026</a:t>
             </a:fld>
             <a:endParaRPr lang="en-US"/>
           </a:p>
@@ -9958,7 +9958,7 @@
         <p:spPr>
           <a:xfrm>
             <a:off x="464048" y="871979"/>
-            <a:ext cx="6393992" cy="220000"/>
+            <a:ext cx="6393992" cy="369332"/>
           </a:xfrm>
           <a:prstGeom prst="rect">
             <a:avLst/>
@@ -9973,7 +9973,7 @@
           <a:p>
             <a:pPr algn="l"/>
             <a:r>
-              <a:rPr sz="2800" b="1" i="0" dirty="0">
+              <a:rPr sz="2400" b="1" i="0" dirty="0">
                 <a:solidFill>
                   <a:srgbClr val="C9A84C"/>
                 </a:solidFill>
@@ -10186,7 +10186,7 @@
         <p:spPr>
           <a:xfrm>
             <a:off x="464048" y="1910000"/>
-            <a:ext cx="3136996" cy="380000"/>
+            <a:ext cx="3136996" cy="492443"/>
           </a:xfrm>
           <a:prstGeom prst="rect">
             <a:avLst/>
@@ -10201,7 +10201,7 @@
           <a:p>
             <a:pPr algn="l"/>
             <a:r>
-              <a:rPr sz="3600" b="1" i="0" dirty="0">
+              <a:rPr sz="3200" b="1" i="0" dirty="0">
                 <a:solidFill>
                   <a:srgbClr val="E5CC7A"/>
                 </a:solidFill>
@@ -10372,7 +10372,7 @@
         <p:spPr>
           <a:xfrm>
             <a:off x="3961044" y="1910000"/>
-            <a:ext cx="3136996" cy="380000"/>
+            <a:ext cx="3136996" cy="492443"/>
           </a:xfrm>
           <a:prstGeom prst="rect">
             <a:avLst/>
@@ -10387,7 +10387,7 @@
           <a:p>
             <a:pPr algn="l"/>
             <a:r>
-              <a:rPr sz="3600" b="1" i="0" dirty="0">
+              <a:rPr sz="3200" b="1" i="0" dirty="0">
                 <a:solidFill>
                   <a:srgbClr val="E5CC7A"/>
                 </a:solidFill>
@@ -10685,7 +10685,7 @@
           <a:p>
             <a:pPr algn="ctr"/>
             <a:r>
-              <a:rPr sz="1800" b="1" i="0">
+              <a:rPr sz="1800" b="1" i="0" dirty="0">
                 <a:solidFill>
                   <a:srgbClr val="182D56"/>
                 </a:solidFill>

</xml_diff>